<commit_message>
updating callout and client pos
</commit_message>
<xml_diff>
--- a/pptgen/outputs/generated_ai_healthcheck.pptx
+++ b/pptgen/outputs/generated_ai_healthcheck.pptx
@@ -6827,7 +6827,7 @@
           <a:p>
             <a:r>
               <a:rPr lang="en-US" err="1"/>
-              <a:t>Celsa</a:t>
+              <a:t>DZ Bank</a:t>
             </a:r>
             <a:r>
               <a:rPr lang="en-US"/>
@@ -13397,7 +13397,7 @@
             </a:r>
             <a:r>
               <a:rPr lang="en-US" err="1"/>
-              <a:t>Celsa</a:t>
+              <a:t>Legálitas</a:t>
             </a:r>
             <a:r>
               <a:rPr lang="en-US"/>
@@ -13644,8 +13644,8 @@
         </p:blipFill>
         <p:spPr>
           <a:xfrm>
-            <a:off x="5564104" y="925907"/>
-            <a:ext cx="200943" cy="215646"/>
+            <a:off x="5564104" y="921826"/>
+            <a:ext cx="428965" cy="223808"/>
           </a:xfrm>
           <a:prstGeom prst="rect">
             <a:avLst/>
@@ -13660,8 +13660,8 @@
         </p:nvSpPr>
         <p:spPr>
           <a:xfrm>
-            <a:off x="5819910" y="925907"/>
-            <a:ext cx="404864" cy="215646"/>
+            <a:off x="6047933" y="921826"/>
+            <a:ext cx="544864" cy="223808"/>
           </a:xfrm>
           <a:prstGeom prst="rect">
             <a:avLst/>
@@ -13677,14 +13677,14 @@
             <a:pPr algn="l"/>
             <a:r>
               <a:rPr sz="1000"/>
-              <a:t>Celsa</a:t>
+              <a:t>DZ Bank</a:t>
             </a:r>
           </a:p>
         </p:txBody>
       </p:sp>
       <p:pic>
         <p:nvPicPr>
-          <p:cNvPr id="4164" name="Picture 4163" descr="arcelormittal_peer_processed.png"/>
+          <p:cNvPr id="4164" name="Picture 4163" descr="bayerische_landesbank_peer_processed.png"/>
           <p:cNvPicPr>
             <a:picLocks noChangeAspect="1"/>
           </p:cNvPicPr>
@@ -13698,8 +13698,8 @@
         </p:blipFill>
         <p:spPr>
           <a:xfrm>
-            <a:off x="7192520" y="925907"/>
-            <a:ext cx="419237" cy="215646"/>
+            <a:off x="7192520" y="921826"/>
+            <a:ext cx="243440" cy="223808"/>
           </a:xfrm>
           <a:prstGeom prst="rect">
             <a:avLst/>
@@ -13714,8 +13714,8 @@
         </p:nvSpPr>
         <p:spPr>
           <a:xfrm>
-            <a:off x="7666621" y="925907"/>
-            <a:ext cx="964864" cy="215646"/>
+            <a:off x="7490824" y="921826"/>
+            <a:ext cx="1524864" cy="223808"/>
           </a:xfrm>
           <a:prstGeom prst="rect">
             <a:avLst/>
@@ -13731,14 +13731,14 @@
             <a:pPr algn="l"/>
             <a:r>
               <a:rPr sz="1000"/>
-              <a:t>ArcelorMittal</a:t>
+              <a:t>Bayerische Landesbank</a:t>
             </a:r>
           </a:p>
         </p:txBody>
       </p:sp>
       <p:pic>
         <p:nvPicPr>
-          <p:cNvPr id="4166" name="Picture 4165" descr="megasa_peer_processed.png"/>
+          <p:cNvPr id="4166" name="Picture 4165" descr="commerzbank_ag_peer_processed.png"/>
           <p:cNvPicPr>
             <a:picLocks noChangeAspect="1"/>
           </p:cNvPicPr>
@@ -13752,8 +13752,8 @@
         </p:blipFill>
         <p:spPr>
           <a:xfrm>
-            <a:off x="8777789" y="925907"/>
-            <a:ext cx="213327" cy="215646"/>
+            <a:off x="9161992" y="921826"/>
+            <a:ext cx="258623" cy="223808"/>
           </a:xfrm>
           <a:prstGeom prst="rect">
             <a:avLst/>
@@ -13768,8 +13768,8 @@
         </p:nvSpPr>
         <p:spPr>
           <a:xfrm>
-            <a:off x="9045980" y="925907"/>
-            <a:ext cx="474864" cy="215646"/>
+            <a:off x="9475478" y="921826"/>
+            <a:ext cx="1034864" cy="223808"/>
           </a:xfrm>
           <a:prstGeom prst="rect">
             <a:avLst/>
@@ -13785,14 +13785,14 @@
             <a:pPr algn="l"/>
             <a:r>
               <a:rPr sz="1000"/>
-              <a:t>Megasa</a:t>
+              <a:t>Commerzbank AG</a:t>
             </a:r>
           </a:p>
         </p:txBody>
       </p:sp>
       <p:pic>
         <p:nvPicPr>
-          <p:cNvPr id="4168" name="Picture 4167" descr="nucor_peer_processed.png"/>
+          <p:cNvPr id="4168" name="Picture 4167" descr="deutsche_bank_ag_peer_processed.png"/>
           <p:cNvPicPr>
             <a:picLocks noChangeAspect="1"/>
           </p:cNvPicPr>
@@ -13806,8 +13806,8 @@
         </p:blipFill>
         <p:spPr>
           <a:xfrm>
-            <a:off x="9667148" y="925907"/>
-            <a:ext cx="328261" cy="215646"/>
+            <a:off x="7192520" y="1218786"/>
+            <a:ext cx="218834" cy="223808"/>
           </a:xfrm>
           <a:prstGeom prst="rect">
             <a:avLst/>
@@ -13822,8 +13822,8 @@
         </p:nvSpPr>
         <p:spPr>
           <a:xfrm>
-            <a:off x="10050273" y="925907"/>
-            <a:ext cx="404864" cy="215646"/>
+            <a:off x="7466218" y="1218786"/>
+            <a:ext cx="1174864" cy="223808"/>
           </a:xfrm>
           <a:prstGeom prst="rect">
             <a:avLst/>
@@ -13839,14 +13839,14 @@
             <a:pPr algn="l"/>
             <a:r>
               <a:rPr sz="1000"/>
-              <a:t>Nucor</a:t>
+              <a:t>Deutsche Bank AG</a:t>
             </a:r>
           </a:p>
         </p:txBody>
       </p:sp>
       <p:pic>
         <p:nvPicPr>
-          <p:cNvPr id="4170" name="Picture 4169" descr="sidenor_peer_processed.png"/>
+          <p:cNvPr id="4170" name="Picture 4169" descr="volkswagen_financial_services_ag_peer_processed.png"/>
           <p:cNvPicPr>
             <a:picLocks noChangeAspect="1"/>
           </p:cNvPicPr>
@@ -13860,8 +13860,8 @@
         </p:blipFill>
         <p:spPr>
           <a:xfrm>
-            <a:off x="10601441" y="925907"/>
-            <a:ext cx="215646" cy="215646"/>
+            <a:off x="8787386" y="1218786"/>
+            <a:ext cx="223808" cy="223808"/>
           </a:xfrm>
           <a:prstGeom prst="rect">
             <a:avLst/>
@@ -13876,8 +13876,8 @@
         </p:nvSpPr>
         <p:spPr>
           <a:xfrm>
-            <a:off x="10871951" y="925907"/>
-            <a:ext cx="544864" cy="215646"/>
+            <a:off x="9066058" y="1218786"/>
+            <a:ext cx="2294864" cy="223808"/>
           </a:xfrm>
           <a:prstGeom prst="rect">
             <a:avLst/>
@@ -13893,14 +13893,110 @@
             <a:pPr algn="l"/>
             <a:r>
               <a:rPr sz="1000"/>
-              <a:t>Sidenor</a:t>
+              <a:t>Volkswagen Financial Services AG</a:t>
             </a:r>
           </a:p>
         </p:txBody>
       </p:sp>
       <p:pic>
         <p:nvPicPr>
-          <p:cNvPr id="4172" name="Picture 4171" descr="megasa_peer_processed.png"/>
+          <p:cNvPr id="4172" name="Picture 4171" descr="bayerische_landesbank_peer_processed.png"/>
+          <p:cNvPicPr>
+            <a:picLocks noChangeAspect="1"/>
+          </p:cNvPicPr>
+          <p:nvPr/>
+        </p:nvPicPr>
+        <p:blipFill>
+          <a:blip r:embed="rId9"/>
+          <a:stretch>
+            <a:fillRect/>
+          </a:stretch>
+        </p:blipFill>
+        <p:spPr>
+          <a:xfrm>
+            <a:off x="9762030" y="1715014"/>
+            <a:ext cx="190188" cy="174850"/>
+          </a:xfrm>
+          <a:prstGeom prst="rect">
+            <a:avLst/>
+          </a:prstGeom>
+        </p:spPr>
+      </p:pic>
+      <p:pic>
+        <p:nvPicPr>
+          <p:cNvPr id="4173" name="Picture 4172" descr="deutsche_bank_ag_peer_processed.png"/>
+          <p:cNvPicPr>
+            <a:picLocks noChangeAspect="1"/>
+          </p:cNvPicPr>
+          <p:nvPr/>
+        </p:nvPicPr>
+        <p:blipFill>
+          <a:blip r:embed="rId11"/>
+          <a:stretch>
+            <a:fillRect/>
+          </a:stretch>
+        </p:blipFill>
+        <p:spPr>
+          <a:xfrm>
+            <a:off x="9956789" y="1715014"/>
+            <a:ext cx="170964" cy="174850"/>
+          </a:xfrm>
+          <a:prstGeom prst="rect">
+            <a:avLst/>
+          </a:prstGeom>
+        </p:spPr>
+      </p:pic>
+      <p:pic>
+        <p:nvPicPr>
+          <p:cNvPr id="4174" name="Picture 4173" descr="volkswagen_financial_services_ag_peer_processed.png"/>
+          <p:cNvPicPr>
+            <a:picLocks noChangeAspect="1"/>
+          </p:cNvPicPr>
+          <p:nvPr/>
+        </p:nvPicPr>
+        <p:blipFill>
+          <a:blip r:embed="rId12"/>
+          <a:stretch>
+            <a:fillRect/>
+          </a:stretch>
+        </p:blipFill>
+        <p:spPr>
+          <a:xfrm>
+            <a:off x="10132325" y="1715014"/>
+            <a:ext cx="174850" cy="174850"/>
+          </a:xfrm>
+          <a:prstGeom prst="rect">
+            <a:avLst/>
+          </a:prstGeom>
+        </p:spPr>
+      </p:pic>
+      <p:pic>
+        <p:nvPicPr>
+          <p:cNvPr id="4175" name="Picture 4174" descr="client_logo_processed.png"/>
+          <p:cNvPicPr>
+            <a:picLocks noChangeAspect="1"/>
+          </p:cNvPicPr>
+          <p:nvPr/>
+        </p:nvPicPr>
+        <p:blipFill>
+          <a:blip r:embed="rId8"/>
+          <a:stretch>
+            <a:fillRect/>
+          </a:stretch>
+        </p:blipFill>
+        <p:spPr>
+          <a:xfrm>
+            <a:off x="10311747" y="1715014"/>
+            <a:ext cx="335129" cy="174850"/>
+          </a:xfrm>
+          <a:prstGeom prst="rect">
+            <a:avLst/>
+          </a:prstGeom>
+        </p:spPr>
+      </p:pic>
+      <p:pic>
+        <p:nvPicPr>
+          <p:cNvPr id="4176" name="Picture 4175" descr="commerzbank_ag_peer_processed.png"/>
           <p:cNvPicPr>
             <a:picLocks noChangeAspect="1"/>
           </p:cNvPicPr>
@@ -13914,8 +14010,8 @@
         </p:blipFill>
         <p:spPr>
           <a:xfrm>
-            <a:off x="8999292" y="1718202"/>
-            <a:ext cx="166662" cy="168474"/>
+            <a:off x="11216516" y="1715014"/>
+            <a:ext cx="202049" cy="174850"/>
           </a:xfrm>
           <a:prstGeom prst="rect">
             <a:avLst/>
@@ -13924,7 +14020,103 @@
       </p:pic>
       <p:pic>
         <p:nvPicPr>
-          <p:cNvPr id="4173" name="Picture 4172" descr="client_logo_processed.png"/>
+          <p:cNvPr id="4177" name="Picture 4176" descr="bayerische_landesbank_peer_processed.png"/>
+          <p:cNvPicPr>
+            <a:picLocks noChangeAspect="1"/>
+          </p:cNvPicPr>
+          <p:nvPr/>
+        </p:nvPicPr>
+        <p:blipFill>
+          <a:blip r:embed="rId9"/>
+          <a:stretch>
+            <a:fillRect/>
+          </a:stretch>
+        </p:blipFill>
+        <p:spPr>
+          <a:xfrm>
+            <a:off x="9658720" y="2146905"/>
+            <a:ext cx="190188" cy="174850"/>
+          </a:xfrm>
+          <a:prstGeom prst="rect">
+            <a:avLst/>
+          </a:prstGeom>
+        </p:spPr>
+      </p:pic>
+      <p:pic>
+        <p:nvPicPr>
+          <p:cNvPr id="4178" name="Picture 4177" descr="commerzbank_ag_peer_processed.png"/>
+          <p:cNvPicPr>
+            <a:picLocks noChangeAspect="1"/>
+          </p:cNvPicPr>
+          <p:nvPr/>
+        </p:nvPicPr>
+        <p:blipFill>
+          <a:blip r:embed="rId10"/>
+          <a:stretch>
+            <a:fillRect/>
+          </a:stretch>
+        </p:blipFill>
+        <p:spPr>
+          <a:xfrm>
+            <a:off x="9853479" y="2146905"/>
+            <a:ext cx="202049" cy="174850"/>
+          </a:xfrm>
+          <a:prstGeom prst="rect">
+            <a:avLst/>
+          </a:prstGeom>
+        </p:spPr>
+      </p:pic>
+      <p:pic>
+        <p:nvPicPr>
+          <p:cNvPr id="4179" name="Picture 4178" descr="deutsche_bank_ag_peer_processed.png"/>
+          <p:cNvPicPr>
+            <a:picLocks noChangeAspect="1"/>
+          </p:cNvPicPr>
+          <p:nvPr/>
+        </p:nvPicPr>
+        <p:blipFill>
+          <a:blip r:embed="rId11"/>
+          <a:stretch>
+            <a:fillRect/>
+          </a:stretch>
+        </p:blipFill>
+        <p:spPr>
+          <a:xfrm>
+            <a:off x="10060099" y="2146905"/>
+            <a:ext cx="170964" cy="174850"/>
+          </a:xfrm>
+          <a:prstGeom prst="rect">
+            <a:avLst/>
+          </a:prstGeom>
+        </p:spPr>
+      </p:pic>
+      <p:pic>
+        <p:nvPicPr>
+          <p:cNvPr id="4180" name="Picture 4179" descr="volkswagen_financial_services_ag_peer_processed.png"/>
+          <p:cNvPicPr>
+            <a:picLocks noChangeAspect="1"/>
+          </p:cNvPicPr>
+          <p:nvPr/>
+        </p:nvPicPr>
+        <p:blipFill>
+          <a:blip r:embed="rId12"/>
+          <a:stretch>
+            <a:fillRect/>
+          </a:stretch>
+        </p:blipFill>
+        <p:spPr>
+          <a:xfrm>
+            <a:off x="10235635" y="2146905"/>
+            <a:ext cx="174850" cy="174850"/>
+          </a:xfrm>
+          <a:prstGeom prst="rect">
+            <a:avLst/>
+          </a:prstGeom>
+        </p:spPr>
+      </p:pic>
+      <p:pic>
+        <p:nvPicPr>
+          <p:cNvPr id="4181" name="Picture 4180" descr="client_logo_processed.png"/>
           <p:cNvPicPr>
             <a:picLocks noChangeAspect="1"/>
           </p:cNvPicPr>
@@ -13938,8 +14130,8 @@
         </p:blipFill>
         <p:spPr>
           <a:xfrm>
-            <a:off x="9742873" y="1718202"/>
-            <a:ext cx="156987" cy="168474"/>
+            <a:off x="10415057" y="2146905"/>
+            <a:ext cx="335129" cy="174850"/>
           </a:xfrm>
           <a:prstGeom prst="rect">
             <a:avLst/>
@@ -13948,7 +14140,7 @@
       </p:pic>
       <p:pic>
         <p:nvPicPr>
-          <p:cNvPr id="4174" name="Picture 4173" descr="arcelormittal_peer_processed.png"/>
+          <p:cNvPr id="4182" name="Picture 4181" descr="bayerische_landesbank_peer_processed.png"/>
           <p:cNvPicPr>
             <a:picLocks noChangeAspect="1"/>
           </p:cNvPicPr>
@@ -13962,8 +14154,8 @@
         </p:blipFill>
         <p:spPr>
           <a:xfrm>
-            <a:off x="9904432" y="1718202"/>
-            <a:ext cx="327530" cy="168474"/>
+            <a:off x="9658720" y="2578796"/>
+            <a:ext cx="190188" cy="174850"/>
           </a:xfrm>
           <a:prstGeom prst="rect">
             <a:avLst/>
@@ -13972,7 +14164,31 @@
       </p:pic>
       <p:pic>
         <p:nvPicPr>
-          <p:cNvPr id="4175" name="Picture 4174" descr="nucor_peer_processed.png"/>
+          <p:cNvPr id="4183" name="Picture 4182" descr="commerzbank_ag_peer_processed.png"/>
+          <p:cNvPicPr>
+            <a:picLocks noChangeAspect="1"/>
+          </p:cNvPicPr>
+          <p:nvPr/>
+        </p:nvPicPr>
+        <p:blipFill>
+          <a:blip r:embed="rId10"/>
+          <a:stretch>
+            <a:fillRect/>
+          </a:stretch>
+        </p:blipFill>
+        <p:spPr>
+          <a:xfrm>
+            <a:off x="9853479" y="2578796"/>
+            <a:ext cx="202049" cy="174850"/>
+          </a:xfrm>
+          <a:prstGeom prst="rect">
+            <a:avLst/>
+          </a:prstGeom>
+        </p:spPr>
+      </p:pic>
+      <p:pic>
+        <p:nvPicPr>
+          <p:cNvPr id="4184" name="Picture 4183" descr="deutsche_bank_ag_peer_processed.png"/>
           <p:cNvPicPr>
             <a:picLocks noChangeAspect="1"/>
           </p:cNvPicPr>
@@ -13986,8 +14202,8 @@
         </p:blipFill>
         <p:spPr>
           <a:xfrm>
-            <a:off x="10236534" y="1718202"/>
-            <a:ext cx="256455" cy="168474"/>
+            <a:off x="10060099" y="2578796"/>
+            <a:ext cx="170964" cy="174850"/>
           </a:xfrm>
           <a:prstGeom prst="rect">
             <a:avLst/>
@@ -13996,7 +14212,7 @@
       </p:pic>
       <p:pic>
         <p:nvPicPr>
-          <p:cNvPr id="4176" name="Picture 4175" descr="sidenor_peer_processed.png"/>
+          <p:cNvPr id="4185" name="Picture 4184" descr="volkswagen_financial_services_ag_peer_processed.png"/>
           <p:cNvPicPr>
             <a:picLocks noChangeAspect="1"/>
           </p:cNvPicPr>
@@ -14010,8 +14226,8 @@
         </p:blipFill>
         <p:spPr>
           <a:xfrm>
-            <a:off x="10497560" y="1718202"/>
-            <a:ext cx="168474" cy="168474"/>
+            <a:off x="10235635" y="2578796"/>
+            <a:ext cx="174850" cy="174850"/>
           </a:xfrm>
           <a:prstGeom prst="rect">
             <a:avLst/>
@@ -14020,7 +14236,55 @@
       </p:pic>
       <p:pic>
         <p:nvPicPr>
-          <p:cNvPr id="4177" name="Picture 4176" descr="megasa_peer_processed.png"/>
+          <p:cNvPr id="4186" name="Picture 4185" descr="client_logo_processed.png"/>
+          <p:cNvPicPr>
+            <a:picLocks noChangeAspect="1"/>
+          </p:cNvPicPr>
+          <p:nvPr/>
+        </p:nvPicPr>
+        <p:blipFill>
+          <a:blip r:embed="rId8"/>
+          <a:stretch>
+            <a:fillRect/>
+          </a:stretch>
+        </p:blipFill>
+        <p:spPr>
+          <a:xfrm>
+            <a:off x="10415057" y="2578796"/>
+            <a:ext cx="335129" cy="174850"/>
+          </a:xfrm>
+          <a:prstGeom prst="rect">
+            <a:avLst/>
+          </a:prstGeom>
+        </p:spPr>
+      </p:pic>
+      <p:pic>
+        <p:nvPicPr>
+          <p:cNvPr id="4187" name="Picture 4186" descr="bayerische_landesbank_peer_processed.png"/>
+          <p:cNvPicPr>
+            <a:picLocks noChangeAspect="1"/>
+          </p:cNvPicPr>
+          <p:nvPr/>
+        </p:nvPicPr>
+        <p:blipFill>
+          <a:blip r:embed="rId9"/>
+          <a:stretch>
+            <a:fillRect/>
+          </a:stretch>
+        </p:blipFill>
+        <p:spPr>
+          <a:xfrm>
+            <a:off x="8884219" y="3010687"/>
+            <a:ext cx="190188" cy="174850"/>
+          </a:xfrm>
+          <a:prstGeom prst="rect">
+            <a:avLst/>
+          </a:prstGeom>
+        </p:spPr>
+      </p:pic>
+      <p:pic>
+        <p:nvPicPr>
+          <p:cNvPr id="4188" name="Picture 4187" descr="commerzbank_ag_peer_processed.png"/>
           <p:cNvPicPr>
             <a:picLocks noChangeAspect="1"/>
           </p:cNvPicPr>
@@ -14034,8 +14298,8 @@
         </p:blipFill>
         <p:spPr>
           <a:xfrm>
-            <a:off x="8782256" y="2150093"/>
-            <a:ext cx="166662" cy="168474"/>
+            <a:off x="9078978" y="3010687"/>
+            <a:ext cx="202049" cy="174850"/>
           </a:xfrm>
           <a:prstGeom prst="rect">
             <a:avLst/>
@@ -14044,7 +14308,7 @@
       </p:pic>
       <p:pic>
         <p:nvPicPr>
-          <p:cNvPr id="4178" name="Picture 4177" descr="nucor_peer_processed.png"/>
+          <p:cNvPr id="4189" name="Picture 4188" descr="deutsche_bank_ag_peer_processed.png"/>
           <p:cNvPicPr>
             <a:picLocks noChangeAspect="1"/>
           </p:cNvPicPr>
@@ -14058,8 +14322,8 @@
         </p:blipFill>
         <p:spPr>
           <a:xfrm>
-            <a:off x="8953490" y="2150093"/>
-            <a:ext cx="256455" cy="168474"/>
+            <a:off x="9859410" y="3010687"/>
+            <a:ext cx="170964" cy="174850"/>
           </a:xfrm>
           <a:prstGeom prst="rect">
             <a:avLst/>
@@ -14068,7 +14332,7 @@
       </p:pic>
       <p:pic>
         <p:nvPicPr>
-          <p:cNvPr id="4179" name="Picture 4178" descr="sidenor_peer_processed.png"/>
+          <p:cNvPr id="4190" name="Picture 4189" descr="volkswagen_financial_services_ag_peer_processed.png"/>
           <p:cNvPicPr>
             <a:picLocks noChangeAspect="1"/>
           </p:cNvPicPr>
@@ -14082,8 +14346,8 @@
         </p:blipFill>
         <p:spPr>
           <a:xfrm>
-            <a:off x="9214516" y="2150093"/>
-            <a:ext cx="168474" cy="168474"/>
+            <a:off x="10034946" y="3010687"/>
+            <a:ext cx="174850" cy="174850"/>
           </a:xfrm>
           <a:prstGeom prst="rect">
             <a:avLst/>
@@ -14092,7 +14356,7 @@
       </p:pic>
       <p:pic>
         <p:nvPicPr>
-          <p:cNvPr id="4180" name="Picture 4179" descr="client_logo_processed.png"/>
+          <p:cNvPr id="4191" name="Picture 4190" descr="client_logo_processed.png"/>
           <p:cNvPicPr>
             <a:picLocks noChangeAspect="1"/>
           </p:cNvPicPr>
@@ -14106,8 +14370,8 @@
         </p:blipFill>
         <p:spPr>
           <a:xfrm>
-            <a:off x="9959909" y="2150093"/>
-            <a:ext cx="156987" cy="168474"/>
+            <a:off x="10214368" y="3010687"/>
+            <a:ext cx="335129" cy="174850"/>
           </a:xfrm>
           <a:prstGeom prst="rect">
             <a:avLst/>
@@ -14116,7 +14380,7 @@
       </p:pic>
       <p:pic>
         <p:nvPicPr>
-          <p:cNvPr id="4181" name="Picture 4180" descr="arcelormittal_peer_processed.png"/>
+          <p:cNvPr id="4192" name="Picture 4191" descr="bayerische_landesbank_peer_processed.png"/>
           <p:cNvPicPr>
             <a:picLocks noChangeAspect="1"/>
           </p:cNvPicPr>
@@ -14130,8 +14394,8 @@
         </p:blipFill>
         <p:spPr>
           <a:xfrm>
-            <a:off x="10121468" y="2150093"/>
-            <a:ext cx="327530" cy="168474"/>
+            <a:off x="9828571" y="3442578"/>
+            <a:ext cx="190188" cy="174850"/>
           </a:xfrm>
           <a:prstGeom prst="rect">
             <a:avLst/>
@@ -14140,7 +14404,7 @@
       </p:pic>
       <p:pic>
         <p:nvPicPr>
-          <p:cNvPr id="4182" name="Picture 4181" descr="megasa_peer_processed.png"/>
+          <p:cNvPr id="4193" name="Picture 4192" descr="commerzbank_ag_peer_processed.png"/>
           <p:cNvPicPr>
             <a:picLocks noChangeAspect="1"/>
           </p:cNvPicPr>
@@ -14154,8 +14418,8 @@
         </p:blipFill>
         <p:spPr>
           <a:xfrm>
-            <a:off x="8999292" y="2581984"/>
-            <a:ext cx="166662" cy="168474"/>
+            <a:off x="10023330" y="3442578"/>
+            <a:ext cx="202049" cy="174850"/>
           </a:xfrm>
           <a:prstGeom prst="rect">
             <a:avLst/>
@@ -14164,7 +14428,55 @@
       </p:pic>
       <p:pic>
         <p:nvPicPr>
-          <p:cNvPr id="4183" name="Picture 4182" descr="client_logo_processed.png"/>
+          <p:cNvPr id="4194" name="Picture 4193" descr="deutsche_bank_ag_peer_processed.png"/>
+          <p:cNvPicPr>
+            <a:picLocks noChangeAspect="1"/>
+          </p:cNvPicPr>
+          <p:nvPr/>
+        </p:nvPicPr>
+        <p:blipFill>
+          <a:blip r:embed="rId11"/>
+          <a:stretch>
+            <a:fillRect/>
+          </a:stretch>
+        </p:blipFill>
+        <p:spPr>
+          <a:xfrm>
+            <a:off x="10229950" y="3442578"/>
+            <a:ext cx="170964" cy="174850"/>
+          </a:xfrm>
+          <a:prstGeom prst="rect">
+            <a:avLst/>
+          </a:prstGeom>
+        </p:spPr>
+      </p:pic>
+      <p:pic>
+        <p:nvPicPr>
+          <p:cNvPr id="4195" name="Picture 4194" descr="volkswagen_financial_services_ag_peer_processed.png"/>
+          <p:cNvPicPr>
+            <a:picLocks noChangeAspect="1"/>
+          </p:cNvPicPr>
+          <p:nvPr/>
+        </p:nvPicPr>
+        <p:blipFill>
+          <a:blip r:embed="rId12"/>
+          <a:stretch>
+            <a:fillRect/>
+          </a:stretch>
+        </p:blipFill>
+        <p:spPr>
+          <a:xfrm>
+            <a:off x="10405486" y="3442578"/>
+            <a:ext cx="174850" cy="174850"/>
+          </a:xfrm>
+          <a:prstGeom prst="rect">
+            <a:avLst/>
+          </a:prstGeom>
+        </p:spPr>
+      </p:pic>
+      <p:pic>
+        <p:nvPicPr>
+          <p:cNvPr id="4196" name="Picture 4195" descr="client_logo_processed.png"/>
           <p:cNvPicPr>
             <a:picLocks noChangeAspect="1"/>
           </p:cNvPicPr>
@@ -14178,8 +14490,8 @@
         </p:blipFill>
         <p:spPr>
           <a:xfrm>
-            <a:off x="9742873" y="2581984"/>
-            <a:ext cx="156987" cy="168474"/>
+            <a:off x="11149975" y="3442578"/>
+            <a:ext cx="335129" cy="174850"/>
           </a:xfrm>
           <a:prstGeom prst="rect">
             <a:avLst/>
@@ -14188,7 +14500,7 @@
       </p:pic>
       <p:pic>
         <p:nvPicPr>
-          <p:cNvPr id="4184" name="Picture 4183" descr="arcelormittal_peer_processed.png"/>
+          <p:cNvPr id="4197" name="Picture 4196" descr="bayerische_landesbank_peer_processed.png"/>
           <p:cNvPicPr>
             <a:picLocks noChangeAspect="1"/>
           </p:cNvPicPr>
@@ -14202,8 +14514,8 @@
         </p:blipFill>
         <p:spPr>
           <a:xfrm>
-            <a:off x="9904432" y="2581984"/>
-            <a:ext cx="327530" cy="168474"/>
+            <a:off x="8817679" y="3874469"/>
+            <a:ext cx="190188" cy="174850"/>
           </a:xfrm>
           <a:prstGeom prst="rect">
             <a:avLst/>
@@ -14212,7 +14524,55 @@
       </p:pic>
       <p:pic>
         <p:nvPicPr>
-          <p:cNvPr id="4185" name="Picture 4184" descr="nucor_peer_processed.png"/>
+          <p:cNvPr id="4198" name="Picture 4197" descr="client_logo_processed.png"/>
+          <p:cNvPicPr>
+            <a:picLocks noChangeAspect="1"/>
+          </p:cNvPicPr>
+          <p:nvPr/>
+        </p:nvPicPr>
+        <p:blipFill>
+          <a:blip r:embed="rId8"/>
+          <a:stretch>
+            <a:fillRect/>
+          </a:stretch>
+        </p:blipFill>
+        <p:spPr>
+          <a:xfrm>
+            <a:off x="9012438" y="3874469"/>
+            <a:ext cx="335129" cy="174850"/>
+          </a:xfrm>
+          <a:prstGeom prst="rect">
+            <a:avLst/>
+          </a:prstGeom>
+        </p:spPr>
+      </p:pic>
+      <p:pic>
+        <p:nvPicPr>
+          <p:cNvPr id="4199" name="Picture 4198" descr="commerzbank_ag_peer_processed.png"/>
+          <p:cNvPicPr>
+            <a:picLocks noChangeAspect="1"/>
+          </p:cNvPicPr>
+          <p:nvPr/>
+        </p:nvPicPr>
+        <p:blipFill>
+          <a:blip r:embed="rId10"/>
+          <a:stretch>
+            <a:fillRect/>
+          </a:stretch>
+        </p:blipFill>
+        <p:spPr>
+          <a:xfrm>
+            <a:off x="9925950" y="3874469"/>
+            <a:ext cx="202049" cy="174850"/>
+          </a:xfrm>
+          <a:prstGeom prst="rect">
+            <a:avLst/>
+          </a:prstGeom>
+        </p:spPr>
+      </p:pic>
+      <p:pic>
+        <p:nvPicPr>
+          <p:cNvPr id="4200" name="Picture 4199" descr="deutsche_bank_ag_peer_processed.png"/>
           <p:cNvPicPr>
             <a:picLocks noChangeAspect="1"/>
           </p:cNvPicPr>
@@ -14226,8 +14586,8 @@
         </p:blipFill>
         <p:spPr>
           <a:xfrm>
-            <a:off x="10236534" y="2581984"/>
-            <a:ext cx="256455" cy="168474"/>
+            <a:off x="10132570" y="3874469"/>
+            <a:ext cx="170964" cy="174850"/>
           </a:xfrm>
           <a:prstGeom prst="rect">
             <a:avLst/>
@@ -14236,7 +14596,7 @@
       </p:pic>
       <p:pic>
         <p:nvPicPr>
-          <p:cNvPr id="4186" name="Picture 4185" descr="sidenor_peer_processed.png"/>
+          <p:cNvPr id="4201" name="Picture 4200" descr="volkswagen_financial_services_ag_peer_processed.png"/>
           <p:cNvPicPr>
             <a:picLocks noChangeAspect="1"/>
           </p:cNvPicPr>
@@ -14250,8 +14610,8 @@
         </p:blipFill>
         <p:spPr>
           <a:xfrm>
-            <a:off x="10497560" y="2581984"/>
-            <a:ext cx="168474" cy="168474"/>
+            <a:off x="10308106" y="3874469"/>
+            <a:ext cx="174850" cy="174850"/>
           </a:xfrm>
           <a:prstGeom prst="rect">
             <a:avLst/>
@@ -14260,7 +14620,79 @@
       </p:pic>
       <p:pic>
         <p:nvPicPr>
-          <p:cNvPr id="4187" name="Picture 4186" descr="client_logo_processed.png"/>
+          <p:cNvPr id="4202" name="Picture 4201" descr="bayerische_landesbank_peer_processed.png"/>
+          <p:cNvPicPr>
+            <a:picLocks noChangeAspect="1"/>
+          </p:cNvPicPr>
+          <p:nvPr/>
+        </p:nvPicPr>
+        <p:blipFill>
+          <a:blip r:embed="rId9"/>
+          <a:stretch>
+            <a:fillRect/>
+          </a:stretch>
+        </p:blipFill>
+        <p:spPr>
+          <a:xfrm>
+            <a:off x="9746488" y="4306360"/>
+            <a:ext cx="190188" cy="174850"/>
+          </a:xfrm>
+          <a:prstGeom prst="rect">
+            <a:avLst/>
+          </a:prstGeom>
+        </p:spPr>
+      </p:pic>
+      <p:pic>
+        <p:nvPicPr>
+          <p:cNvPr id="4203" name="Picture 4202" descr="commerzbank_ag_peer_processed.png"/>
+          <p:cNvPicPr>
+            <a:picLocks noChangeAspect="1"/>
+          </p:cNvPicPr>
+          <p:nvPr/>
+        </p:nvPicPr>
+        <p:blipFill>
+          <a:blip r:embed="rId10"/>
+          <a:stretch>
+            <a:fillRect/>
+          </a:stretch>
+        </p:blipFill>
+        <p:spPr>
+          <a:xfrm>
+            <a:off x="9941247" y="4306360"/>
+            <a:ext cx="202049" cy="174850"/>
+          </a:xfrm>
+          <a:prstGeom prst="rect">
+            <a:avLst/>
+          </a:prstGeom>
+        </p:spPr>
+      </p:pic>
+      <p:pic>
+        <p:nvPicPr>
+          <p:cNvPr id="4204" name="Picture 4203" descr="volkswagen_financial_services_ag_peer_processed.png"/>
+          <p:cNvPicPr>
+            <a:picLocks noChangeAspect="1"/>
+          </p:cNvPicPr>
+          <p:nvPr/>
+        </p:nvPicPr>
+        <p:blipFill>
+          <a:blip r:embed="rId12"/>
+          <a:stretch>
+            <a:fillRect/>
+          </a:stretch>
+        </p:blipFill>
+        <p:spPr>
+          <a:xfrm>
+            <a:off x="10147867" y="4306360"/>
+            <a:ext cx="174850" cy="174850"/>
+          </a:xfrm>
+          <a:prstGeom prst="rect">
+            <a:avLst/>
+          </a:prstGeom>
+        </p:spPr>
+      </p:pic>
+      <p:pic>
+        <p:nvPicPr>
+          <p:cNvPr id="4205" name="Picture 4204" descr="client_logo_processed.png"/>
           <p:cNvPicPr>
             <a:picLocks noChangeAspect="1"/>
           </p:cNvPicPr>
@@ -14274,8 +14706,8 @@
         </p:blipFill>
         <p:spPr>
           <a:xfrm>
-            <a:off x="8831989" y="3013875"/>
-            <a:ext cx="156987" cy="168474"/>
+            <a:off x="10327289" y="4306360"/>
+            <a:ext cx="335129" cy="174850"/>
           </a:xfrm>
           <a:prstGeom prst="rect">
             <a:avLst/>
@@ -14284,7 +14716,55 @@
       </p:pic>
       <p:pic>
         <p:nvPicPr>
-          <p:cNvPr id="4188" name="Picture 4187" descr="megasa_peer_processed.png"/>
+          <p:cNvPr id="4206" name="Picture 4205" descr="deutsche_bank_ag_peer_processed.png"/>
+          <p:cNvPicPr>
+            <a:picLocks noChangeAspect="1"/>
+          </p:cNvPicPr>
+          <p:nvPr/>
+        </p:nvPicPr>
+        <p:blipFill>
+          <a:blip r:embed="rId11"/>
+          <a:stretch>
+            <a:fillRect/>
+          </a:stretch>
+        </p:blipFill>
+        <p:spPr>
+          <a:xfrm>
+            <a:off x="11232058" y="4306360"/>
+            <a:ext cx="170964" cy="174850"/>
+          </a:xfrm>
+          <a:prstGeom prst="rect">
+            <a:avLst/>
+          </a:prstGeom>
+        </p:spPr>
+      </p:pic>
+      <p:pic>
+        <p:nvPicPr>
+          <p:cNvPr id="4207" name="Picture 4206" descr="bayerische_landesbank_peer_processed.png"/>
+          <p:cNvPicPr>
+            <a:picLocks noChangeAspect="1"/>
+          </p:cNvPicPr>
+          <p:nvPr/>
+        </p:nvPicPr>
+        <p:blipFill>
+          <a:blip r:embed="rId9"/>
+          <a:stretch>
+            <a:fillRect/>
+          </a:stretch>
+        </p:blipFill>
+        <p:spPr>
+          <a:xfrm>
+            <a:off x="9828571" y="4738251"/>
+            <a:ext cx="190188" cy="174850"/>
+          </a:xfrm>
+          <a:prstGeom prst="rect">
+            <a:avLst/>
+          </a:prstGeom>
+        </p:spPr>
+      </p:pic>
+      <p:pic>
+        <p:nvPicPr>
+          <p:cNvPr id="4208" name="Picture 4207" descr="commerzbank_ag_peer_processed.png"/>
           <p:cNvPicPr>
             <a:picLocks noChangeAspect="1"/>
           </p:cNvPicPr>
@@ -14298,8 +14778,8 @@
         </p:blipFill>
         <p:spPr>
           <a:xfrm>
-            <a:off x="8993548" y="3013875"/>
-            <a:ext cx="166662" cy="168474"/>
+            <a:off x="10023330" y="4738251"/>
+            <a:ext cx="202049" cy="174850"/>
           </a:xfrm>
           <a:prstGeom prst="rect">
             <a:avLst/>
@@ -14308,7 +14788,31 @@
       </p:pic>
       <p:pic>
         <p:nvPicPr>
-          <p:cNvPr id="4189" name="Picture 4188" descr="sidenor_peer_processed.png"/>
+          <p:cNvPr id="4209" name="Picture 4208" descr="deutsche_bank_ag_peer_processed.png"/>
+          <p:cNvPicPr>
+            <a:picLocks noChangeAspect="1"/>
+          </p:cNvPicPr>
+          <p:nvPr/>
+        </p:nvPicPr>
+        <p:blipFill>
+          <a:blip r:embed="rId11"/>
+          <a:stretch>
+            <a:fillRect/>
+          </a:stretch>
+        </p:blipFill>
+        <p:spPr>
+          <a:xfrm>
+            <a:off x="10229950" y="4738251"/>
+            <a:ext cx="170964" cy="174850"/>
+          </a:xfrm>
+          <a:prstGeom prst="rect">
+            <a:avLst/>
+          </a:prstGeom>
+        </p:spPr>
+      </p:pic>
+      <p:pic>
+        <p:nvPicPr>
+          <p:cNvPr id="4210" name="Picture 4209" descr="volkswagen_financial_services_ag_peer_processed.png"/>
           <p:cNvPicPr>
             <a:picLocks noChangeAspect="1"/>
           </p:cNvPicPr>
@@ -14322,8 +14826,8 @@
         </p:blipFill>
         <p:spPr>
           <a:xfrm>
-            <a:off x="9164782" y="3013875"/>
-            <a:ext cx="168474" cy="168474"/>
+            <a:off x="10405486" y="4738251"/>
+            <a:ext cx="174850" cy="174850"/>
           </a:xfrm>
           <a:prstGeom prst="rect">
             <a:avLst/>
@@ -14332,7 +14836,31 @@
       </p:pic>
       <p:pic>
         <p:nvPicPr>
-          <p:cNvPr id="4190" name="Picture 4189" descr="arcelormittal_peer_processed.png"/>
+          <p:cNvPr id="4211" name="Picture 4210" descr="client_logo_processed.png"/>
+          <p:cNvPicPr>
+            <a:picLocks noChangeAspect="1"/>
+          </p:cNvPicPr>
+          <p:nvPr/>
+        </p:nvPicPr>
+        <p:blipFill>
+          <a:blip r:embed="rId8"/>
+          <a:stretch>
+            <a:fillRect/>
+          </a:stretch>
+        </p:blipFill>
+        <p:spPr>
+          <a:xfrm>
+            <a:off x="11149975" y="4738251"/>
+            <a:ext cx="335129" cy="174850"/>
+          </a:xfrm>
+          <a:prstGeom prst="rect">
+            <a:avLst/>
+          </a:prstGeom>
+        </p:spPr>
+      </p:pic>
+      <p:pic>
+        <p:nvPicPr>
+          <p:cNvPr id="4212" name="Picture 4211" descr="bayerische_landesbank_peer_processed.png"/>
           <p:cNvPicPr>
             <a:picLocks noChangeAspect="1"/>
           </p:cNvPicPr>
@@ -14346,8 +14874,8 @@
         </p:blipFill>
         <p:spPr>
           <a:xfrm>
-            <a:off x="9910175" y="3013875"/>
-            <a:ext cx="327530" cy="168474"/>
+            <a:off x="9746488" y="5170142"/>
+            <a:ext cx="190188" cy="174850"/>
           </a:xfrm>
           <a:prstGeom prst="rect">
             <a:avLst/>
@@ -14356,7 +14884,79 @@
       </p:pic>
       <p:pic>
         <p:nvPicPr>
-          <p:cNvPr id="4191" name="Picture 4190" descr="nucor_peer_processed.png"/>
+          <p:cNvPr id="4213" name="Picture 4212" descr="commerzbank_ag_peer_processed.png"/>
+          <p:cNvPicPr>
+            <a:picLocks noChangeAspect="1"/>
+          </p:cNvPicPr>
+          <p:nvPr/>
+        </p:nvPicPr>
+        <p:blipFill>
+          <a:blip r:embed="rId10"/>
+          <a:stretch>
+            <a:fillRect/>
+          </a:stretch>
+        </p:blipFill>
+        <p:spPr>
+          <a:xfrm>
+            <a:off x="9941247" y="5170142"/>
+            <a:ext cx="202049" cy="174850"/>
+          </a:xfrm>
+          <a:prstGeom prst="rect">
+            <a:avLst/>
+          </a:prstGeom>
+        </p:spPr>
+      </p:pic>
+      <p:pic>
+        <p:nvPicPr>
+          <p:cNvPr id="4214" name="Picture 4213" descr="volkswagen_financial_services_ag_peer_processed.png"/>
+          <p:cNvPicPr>
+            <a:picLocks noChangeAspect="1"/>
+          </p:cNvPicPr>
+          <p:nvPr/>
+        </p:nvPicPr>
+        <p:blipFill>
+          <a:blip r:embed="rId12"/>
+          <a:stretch>
+            <a:fillRect/>
+          </a:stretch>
+        </p:blipFill>
+        <p:spPr>
+          <a:xfrm>
+            <a:off x="10147867" y="5170142"/>
+            <a:ext cx="174850" cy="174850"/>
+          </a:xfrm>
+          <a:prstGeom prst="rect">
+            <a:avLst/>
+          </a:prstGeom>
+        </p:spPr>
+      </p:pic>
+      <p:pic>
+        <p:nvPicPr>
+          <p:cNvPr id="4215" name="Picture 4214" descr="client_logo_processed.png"/>
+          <p:cNvPicPr>
+            <a:picLocks noChangeAspect="1"/>
+          </p:cNvPicPr>
+          <p:nvPr/>
+        </p:nvPicPr>
+        <p:blipFill>
+          <a:blip r:embed="rId8"/>
+          <a:stretch>
+            <a:fillRect/>
+          </a:stretch>
+        </p:blipFill>
+        <p:spPr>
+          <a:xfrm>
+            <a:off x="10327289" y="5170142"/>
+            <a:ext cx="335129" cy="174850"/>
+          </a:xfrm>
+          <a:prstGeom prst="rect">
+            <a:avLst/>
+          </a:prstGeom>
+        </p:spPr>
+      </p:pic>
+      <p:pic>
+        <p:nvPicPr>
+          <p:cNvPr id="4216" name="Picture 4215" descr="deutsche_bank_ag_peer_processed.png"/>
           <p:cNvPicPr>
             <a:picLocks noChangeAspect="1"/>
           </p:cNvPicPr>
@@ -14370,8 +14970,8 @@
         </p:blipFill>
         <p:spPr>
           <a:xfrm>
-            <a:off x="10242277" y="3013875"/>
-            <a:ext cx="256455" cy="168474"/>
+            <a:off x="11232058" y="5170142"/>
+            <a:ext cx="170964" cy="174850"/>
           </a:xfrm>
           <a:prstGeom prst="rect">
             <a:avLst/>
@@ -14380,7 +14980,31 @@
       </p:pic>
       <p:pic>
         <p:nvPicPr>
-          <p:cNvPr id="4192" name="Picture 4191" descr="megasa_peer_processed.png"/>
+          <p:cNvPr id="4217" name="Picture 4216" descr="bayerische_landesbank_peer_processed.png"/>
+          <p:cNvPicPr>
+            <a:picLocks noChangeAspect="1"/>
+          </p:cNvPicPr>
+          <p:nvPr/>
+        </p:nvPicPr>
+        <p:blipFill>
+          <a:blip r:embed="rId9"/>
+          <a:stretch>
+            <a:fillRect/>
+          </a:stretch>
+        </p:blipFill>
+        <p:spPr>
+          <a:xfrm>
+            <a:off x="9658720" y="5602033"/>
+            <a:ext cx="190188" cy="174850"/>
+          </a:xfrm>
+          <a:prstGeom prst="rect">
+            <a:avLst/>
+          </a:prstGeom>
+        </p:spPr>
+      </p:pic>
+      <p:pic>
+        <p:nvPicPr>
+          <p:cNvPr id="4218" name="Picture 4217" descr="commerzbank_ag_peer_processed.png"/>
           <p:cNvPicPr>
             <a:picLocks noChangeAspect="1"/>
           </p:cNvPicPr>
@@ -14394,8 +15018,8 @@
         </p:blipFill>
         <p:spPr>
           <a:xfrm>
-            <a:off x="8999292" y="3445766"/>
-            <a:ext cx="166662" cy="168474"/>
+            <a:off x="9853479" y="5602033"/>
+            <a:ext cx="202049" cy="174850"/>
           </a:xfrm>
           <a:prstGeom prst="rect">
             <a:avLst/>
@@ -14404,7 +15028,55 @@
       </p:pic>
       <p:pic>
         <p:nvPicPr>
-          <p:cNvPr id="4193" name="Picture 4192" descr="client_logo_processed.png"/>
+          <p:cNvPr id="4219" name="Picture 4218" descr="deutsche_bank_ag_peer_processed.png"/>
+          <p:cNvPicPr>
+            <a:picLocks noChangeAspect="1"/>
+          </p:cNvPicPr>
+          <p:nvPr/>
+        </p:nvPicPr>
+        <p:blipFill>
+          <a:blip r:embed="rId11"/>
+          <a:stretch>
+            <a:fillRect/>
+          </a:stretch>
+        </p:blipFill>
+        <p:spPr>
+          <a:xfrm>
+            <a:off x="10060099" y="5602033"/>
+            <a:ext cx="170964" cy="174850"/>
+          </a:xfrm>
+          <a:prstGeom prst="rect">
+            <a:avLst/>
+          </a:prstGeom>
+        </p:spPr>
+      </p:pic>
+      <p:pic>
+        <p:nvPicPr>
+          <p:cNvPr id="4220" name="Picture 4219" descr="volkswagen_financial_services_ag_peer_processed.png"/>
+          <p:cNvPicPr>
+            <a:picLocks noChangeAspect="1"/>
+          </p:cNvPicPr>
+          <p:nvPr/>
+        </p:nvPicPr>
+        <p:blipFill>
+          <a:blip r:embed="rId12"/>
+          <a:stretch>
+            <a:fillRect/>
+          </a:stretch>
+        </p:blipFill>
+        <p:spPr>
+          <a:xfrm>
+            <a:off x="10235635" y="5602033"/>
+            <a:ext cx="174850" cy="174850"/>
+          </a:xfrm>
+          <a:prstGeom prst="rect">
+            <a:avLst/>
+          </a:prstGeom>
+        </p:spPr>
+      </p:pic>
+      <p:pic>
+        <p:nvPicPr>
+          <p:cNvPr id="4221" name="Picture 4220" descr="client_logo_processed.png"/>
           <p:cNvPicPr>
             <a:picLocks noChangeAspect="1"/>
           </p:cNvPicPr>
@@ -14418,8 +15090,8 @@
         </p:blipFill>
         <p:spPr>
           <a:xfrm>
-            <a:off x="9742873" y="3445766"/>
-            <a:ext cx="156987" cy="168474"/>
+            <a:off x="10415057" y="5602033"/>
+            <a:ext cx="335129" cy="174850"/>
           </a:xfrm>
           <a:prstGeom prst="rect">
             <a:avLst/>
@@ -14428,7 +15100,7 @@
       </p:pic>
       <p:pic>
         <p:nvPicPr>
-          <p:cNvPr id="4194" name="Picture 4193" descr="arcelormittal_peer_processed.png"/>
+          <p:cNvPr id="4222" name="Picture 4221" descr="bayerische_landesbank_peer_processed.png"/>
           <p:cNvPicPr>
             <a:picLocks noChangeAspect="1"/>
           </p:cNvPicPr>
@@ -14442,8 +15114,8 @@
         </p:blipFill>
         <p:spPr>
           <a:xfrm>
-            <a:off x="9904432" y="3445766"/>
-            <a:ext cx="327530" cy="168474"/>
+            <a:off x="9658720" y="6033924"/>
+            <a:ext cx="190188" cy="174850"/>
           </a:xfrm>
           <a:prstGeom prst="rect">
             <a:avLst/>
@@ -14452,7 +15124,31 @@
       </p:pic>
       <p:pic>
         <p:nvPicPr>
-          <p:cNvPr id="4195" name="Picture 4194" descr="nucor_peer_processed.png"/>
+          <p:cNvPr id="4223" name="Picture 4222" descr="commerzbank_ag_peer_processed.png"/>
+          <p:cNvPicPr>
+            <a:picLocks noChangeAspect="1"/>
+          </p:cNvPicPr>
+          <p:nvPr/>
+        </p:nvPicPr>
+        <p:blipFill>
+          <a:blip r:embed="rId10"/>
+          <a:stretch>
+            <a:fillRect/>
+          </a:stretch>
+        </p:blipFill>
+        <p:spPr>
+          <a:xfrm>
+            <a:off x="9853479" y="6033924"/>
+            <a:ext cx="202049" cy="174850"/>
+          </a:xfrm>
+          <a:prstGeom prst="rect">
+            <a:avLst/>
+          </a:prstGeom>
+        </p:spPr>
+      </p:pic>
+      <p:pic>
+        <p:nvPicPr>
+          <p:cNvPr id="4224" name="Picture 4223" descr="deutsche_bank_ag_peer_processed.png"/>
           <p:cNvPicPr>
             <a:picLocks noChangeAspect="1"/>
           </p:cNvPicPr>
@@ -14466,8 +15162,8 @@
         </p:blipFill>
         <p:spPr>
           <a:xfrm>
-            <a:off x="10236534" y="3445766"/>
-            <a:ext cx="256455" cy="168474"/>
+            <a:off x="10060099" y="6033924"/>
+            <a:ext cx="170964" cy="174850"/>
           </a:xfrm>
           <a:prstGeom prst="rect">
             <a:avLst/>
@@ -14476,7 +15172,7 @@
       </p:pic>
       <p:pic>
         <p:nvPicPr>
-          <p:cNvPr id="4196" name="Picture 4195" descr="sidenor_peer_processed.png"/>
+          <p:cNvPr id="4225" name="Picture 4224" descr="volkswagen_financial_services_ag_peer_processed.png"/>
           <p:cNvPicPr>
             <a:picLocks noChangeAspect="1"/>
           </p:cNvPicPr>
@@ -14490,8 +15186,8 @@
         </p:blipFill>
         <p:spPr>
           <a:xfrm>
-            <a:off x="10497560" y="3445766"/>
-            <a:ext cx="168474" cy="168474"/>
+            <a:off x="10235635" y="6033924"/>
+            <a:ext cx="174850" cy="174850"/>
           </a:xfrm>
           <a:prstGeom prst="rect">
             <a:avLst/>
@@ -14500,7 +15196,7 @@
       </p:pic>
       <p:pic>
         <p:nvPicPr>
-          <p:cNvPr id="4197" name="Picture 4196" descr="client_logo_processed.png"/>
+          <p:cNvPr id="4226" name="Picture 4225" descr="client_logo_processed.png"/>
           <p:cNvPicPr>
             <a:picLocks noChangeAspect="1"/>
           </p:cNvPicPr>
@@ -14514,704 +15210,8 @@
         </p:blipFill>
         <p:spPr>
           <a:xfrm>
-            <a:off x="8701476" y="3877657"/>
-            <a:ext cx="156987" cy="168474"/>
-          </a:xfrm>
-          <a:prstGeom prst="rect">
-            <a:avLst/>
-          </a:prstGeom>
-        </p:spPr>
-      </p:pic>
-      <p:pic>
-        <p:nvPicPr>
-          <p:cNvPr id="4198" name="Picture 4197" descr="megasa_peer_processed.png"/>
-          <p:cNvPicPr>
-            <a:picLocks noChangeAspect="1"/>
-          </p:cNvPicPr>
-          <p:nvPr/>
-        </p:nvPicPr>
-        <p:blipFill>
-          <a:blip r:embed="rId10"/>
-          <a:stretch>
-            <a:fillRect/>
-          </a:stretch>
-        </p:blipFill>
-        <p:spPr>
-          <a:xfrm>
-            <a:off x="8863035" y="3877657"/>
-            <a:ext cx="166662" cy="168474"/>
-          </a:xfrm>
-          <a:prstGeom prst="rect">
-            <a:avLst/>
-          </a:prstGeom>
-        </p:spPr>
-      </p:pic>
-      <p:pic>
-        <p:nvPicPr>
-          <p:cNvPr id="4199" name="Picture 4198" descr="nucor_peer_processed.png"/>
-          <p:cNvPicPr>
-            <a:picLocks noChangeAspect="1"/>
-          </p:cNvPicPr>
-          <p:nvPr/>
-        </p:nvPicPr>
-        <p:blipFill>
-          <a:blip r:embed="rId11"/>
-          <a:stretch>
-            <a:fillRect/>
-          </a:stretch>
-        </p:blipFill>
-        <p:spPr>
-          <a:xfrm>
-            <a:off x="9034269" y="3877657"/>
-            <a:ext cx="256455" cy="168474"/>
-          </a:xfrm>
-          <a:prstGeom prst="rect">
-            <a:avLst/>
-          </a:prstGeom>
-        </p:spPr>
-      </p:pic>
-      <p:pic>
-        <p:nvPicPr>
-          <p:cNvPr id="4200" name="Picture 4199" descr="sidenor_peer_processed.png"/>
-          <p:cNvPicPr>
-            <a:picLocks noChangeAspect="1"/>
-          </p:cNvPicPr>
-          <p:nvPr/>
-        </p:nvPicPr>
-        <p:blipFill>
-          <a:blip r:embed="rId12"/>
-          <a:stretch>
-            <a:fillRect/>
-          </a:stretch>
-        </p:blipFill>
-        <p:spPr>
-          <a:xfrm>
-            <a:off x="9295295" y="3877657"/>
-            <a:ext cx="168474" cy="168474"/>
-          </a:xfrm>
-          <a:prstGeom prst="rect">
-            <a:avLst/>
-          </a:prstGeom>
-        </p:spPr>
-      </p:pic>
-      <p:pic>
-        <p:nvPicPr>
-          <p:cNvPr id="4201" name="Picture 4200" descr="arcelormittal_peer_processed.png"/>
-          <p:cNvPicPr>
-            <a:picLocks noChangeAspect="1"/>
-          </p:cNvPicPr>
-          <p:nvPr/>
-        </p:nvPicPr>
-        <p:blipFill>
-          <a:blip r:embed="rId9"/>
-          <a:stretch>
-            <a:fillRect/>
-          </a:stretch>
-        </p:blipFill>
-        <p:spPr>
-          <a:xfrm>
-            <a:off x="10040688" y="3877657"/>
-            <a:ext cx="327530" cy="168474"/>
-          </a:xfrm>
-          <a:prstGeom prst="rect">
-            <a:avLst/>
-          </a:prstGeom>
-        </p:spPr>
-      </p:pic>
-      <p:pic>
-        <p:nvPicPr>
-          <p:cNvPr id="4202" name="Picture 4201" descr="client_logo_processed.png"/>
-          <p:cNvPicPr>
-            <a:picLocks noChangeAspect="1"/>
-          </p:cNvPicPr>
-          <p:nvPr/>
-        </p:nvPicPr>
-        <p:blipFill>
-          <a:blip r:embed="rId8"/>
-          <a:stretch>
-            <a:fillRect/>
-          </a:stretch>
-        </p:blipFill>
-        <p:spPr>
-          <a:xfrm>
-            <a:off x="8701476" y="4309548"/>
-            <a:ext cx="156987" cy="168474"/>
-          </a:xfrm>
-          <a:prstGeom prst="rect">
-            <a:avLst/>
-          </a:prstGeom>
-        </p:spPr>
-      </p:pic>
-      <p:pic>
-        <p:nvPicPr>
-          <p:cNvPr id="4203" name="Picture 4202" descr="megasa_peer_processed.png"/>
-          <p:cNvPicPr>
-            <a:picLocks noChangeAspect="1"/>
-          </p:cNvPicPr>
-          <p:nvPr/>
-        </p:nvPicPr>
-        <p:blipFill>
-          <a:blip r:embed="rId10"/>
-          <a:stretch>
-            <a:fillRect/>
-          </a:stretch>
-        </p:blipFill>
-        <p:spPr>
-          <a:xfrm>
-            <a:off x="8863035" y="4309548"/>
-            <a:ext cx="166662" cy="168474"/>
-          </a:xfrm>
-          <a:prstGeom prst="rect">
-            <a:avLst/>
-          </a:prstGeom>
-        </p:spPr>
-      </p:pic>
-      <p:pic>
-        <p:nvPicPr>
-          <p:cNvPr id="4204" name="Picture 4203" descr="nucor_peer_processed.png"/>
-          <p:cNvPicPr>
-            <a:picLocks noChangeAspect="1"/>
-          </p:cNvPicPr>
-          <p:nvPr/>
-        </p:nvPicPr>
-        <p:blipFill>
-          <a:blip r:embed="rId11"/>
-          <a:stretch>
-            <a:fillRect/>
-          </a:stretch>
-        </p:blipFill>
-        <p:spPr>
-          <a:xfrm>
-            <a:off x="9034269" y="4309548"/>
-            <a:ext cx="256455" cy="168474"/>
-          </a:xfrm>
-          <a:prstGeom prst="rect">
-            <a:avLst/>
-          </a:prstGeom>
-        </p:spPr>
-      </p:pic>
-      <p:pic>
-        <p:nvPicPr>
-          <p:cNvPr id="4205" name="Picture 4204" descr="sidenor_peer_processed.png"/>
-          <p:cNvPicPr>
-            <a:picLocks noChangeAspect="1"/>
-          </p:cNvPicPr>
-          <p:nvPr/>
-        </p:nvPicPr>
-        <p:blipFill>
-          <a:blip r:embed="rId12"/>
-          <a:stretch>
-            <a:fillRect/>
-          </a:stretch>
-        </p:blipFill>
-        <p:spPr>
-          <a:xfrm>
-            <a:off x="9295295" y="4309548"/>
-            <a:ext cx="168474" cy="168474"/>
-          </a:xfrm>
-          <a:prstGeom prst="rect">
-            <a:avLst/>
-          </a:prstGeom>
-        </p:spPr>
-      </p:pic>
-      <p:pic>
-        <p:nvPicPr>
-          <p:cNvPr id="4206" name="Picture 4205" descr="arcelormittal_peer_processed.png"/>
-          <p:cNvPicPr>
-            <a:picLocks noChangeAspect="1"/>
-          </p:cNvPicPr>
-          <p:nvPr/>
-        </p:nvPicPr>
-        <p:blipFill>
-          <a:blip r:embed="rId9"/>
-          <a:stretch>
-            <a:fillRect/>
-          </a:stretch>
-        </p:blipFill>
-        <p:spPr>
-          <a:xfrm>
-            <a:off x="10040688" y="4309548"/>
-            <a:ext cx="327530" cy="168474"/>
-          </a:xfrm>
-          <a:prstGeom prst="rect">
-            <a:avLst/>
-          </a:prstGeom>
-        </p:spPr>
-      </p:pic>
-      <p:pic>
-        <p:nvPicPr>
-          <p:cNvPr id="4207" name="Picture 4206" descr="megasa_peer_processed.png"/>
-          <p:cNvPicPr>
-            <a:picLocks noChangeAspect="1"/>
-          </p:cNvPicPr>
-          <p:nvPr/>
-        </p:nvPicPr>
-        <p:blipFill>
-          <a:blip r:embed="rId10"/>
-          <a:stretch>
-            <a:fillRect/>
-          </a:stretch>
-        </p:blipFill>
-        <p:spPr>
-          <a:xfrm>
-            <a:off x="8999292" y="4741439"/>
-            <a:ext cx="166662" cy="168474"/>
-          </a:xfrm>
-          <a:prstGeom prst="rect">
-            <a:avLst/>
-          </a:prstGeom>
-        </p:spPr>
-      </p:pic>
-      <p:pic>
-        <p:nvPicPr>
-          <p:cNvPr id="4208" name="Picture 4207" descr="client_logo_processed.png"/>
-          <p:cNvPicPr>
-            <a:picLocks noChangeAspect="1"/>
-          </p:cNvPicPr>
-          <p:nvPr/>
-        </p:nvPicPr>
-        <p:blipFill>
-          <a:blip r:embed="rId8"/>
-          <a:stretch>
-            <a:fillRect/>
-          </a:stretch>
-        </p:blipFill>
-        <p:spPr>
-          <a:xfrm>
-            <a:off x="9742873" y="4741439"/>
-            <a:ext cx="156987" cy="168474"/>
-          </a:xfrm>
-          <a:prstGeom prst="rect">
-            <a:avLst/>
-          </a:prstGeom>
-        </p:spPr>
-      </p:pic>
-      <p:pic>
-        <p:nvPicPr>
-          <p:cNvPr id="4209" name="Picture 4208" descr="arcelormittal_peer_processed.png"/>
-          <p:cNvPicPr>
-            <a:picLocks noChangeAspect="1"/>
-          </p:cNvPicPr>
-          <p:nvPr/>
-        </p:nvPicPr>
-        <p:blipFill>
-          <a:blip r:embed="rId9"/>
-          <a:stretch>
-            <a:fillRect/>
-          </a:stretch>
-        </p:blipFill>
-        <p:spPr>
-          <a:xfrm>
-            <a:off x="9904432" y="4741439"/>
-            <a:ext cx="327530" cy="168474"/>
-          </a:xfrm>
-          <a:prstGeom prst="rect">
-            <a:avLst/>
-          </a:prstGeom>
-        </p:spPr>
-      </p:pic>
-      <p:pic>
-        <p:nvPicPr>
-          <p:cNvPr id="4210" name="Picture 4209" descr="nucor_peer_processed.png"/>
-          <p:cNvPicPr>
-            <a:picLocks noChangeAspect="1"/>
-          </p:cNvPicPr>
-          <p:nvPr/>
-        </p:nvPicPr>
-        <p:blipFill>
-          <a:blip r:embed="rId11"/>
-          <a:stretch>
-            <a:fillRect/>
-          </a:stretch>
-        </p:blipFill>
-        <p:spPr>
-          <a:xfrm>
-            <a:off x="10236534" y="4741439"/>
-            <a:ext cx="256455" cy="168474"/>
-          </a:xfrm>
-          <a:prstGeom prst="rect">
-            <a:avLst/>
-          </a:prstGeom>
-        </p:spPr>
-      </p:pic>
-      <p:pic>
-        <p:nvPicPr>
-          <p:cNvPr id="4211" name="Picture 4210" descr="sidenor_peer_processed.png"/>
-          <p:cNvPicPr>
-            <a:picLocks noChangeAspect="1"/>
-          </p:cNvPicPr>
-          <p:nvPr/>
-        </p:nvPicPr>
-        <p:blipFill>
-          <a:blip r:embed="rId12"/>
-          <a:stretch>
-            <a:fillRect/>
-          </a:stretch>
-        </p:blipFill>
-        <p:spPr>
-          <a:xfrm>
-            <a:off x="10497560" y="4741439"/>
-            <a:ext cx="168474" cy="168474"/>
-          </a:xfrm>
-          <a:prstGeom prst="rect">
-            <a:avLst/>
-          </a:prstGeom>
-        </p:spPr>
-      </p:pic>
-      <p:pic>
-        <p:nvPicPr>
-          <p:cNvPr id="4212" name="Picture 4211" descr="megasa_peer_processed.png"/>
-          <p:cNvPicPr>
-            <a:picLocks noChangeAspect="1"/>
-          </p:cNvPicPr>
-          <p:nvPr/>
-        </p:nvPicPr>
-        <p:blipFill>
-          <a:blip r:embed="rId10"/>
-          <a:stretch>
-            <a:fillRect/>
-          </a:stretch>
-        </p:blipFill>
-        <p:spPr>
-          <a:xfrm>
-            <a:off x="8999292" y="5173330"/>
-            <a:ext cx="166662" cy="168474"/>
-          </a:xfrm>
-          <a:prstGeom prst="rect">
-            <a:avLst/>
-          </a:prstGeom>
-        </p:spPr>
-      </p:pic>
-      <p:pic>
-        <p:nvPicPr>
-          <p:cNvPr id="4213" name="Picture 4212" descr="client_logo_processed.png"/>
-          <p:cNvPicPr>
-            <a:picLocks noChangeAspect="1"/>
-          </p:cNvPicPr>
-          <p:nvPr/>
-        </p:nvPicPr>
-        <p:blipFill>
-          <a:blip r:embed="rId8"/>
-          <a:stretch>
-            <a:fillRect/>
-          </a:stretch>
-        </p:blipFill>
-        <p:spPr>
-          <a:xfrm>
-            <a:off x="9742873" y="5173330"/>
-            <a:ext cx="156987" cy="168474"/>
-          </a:xfrm>
-          <a:prstGeom prst="rect">
-            <a:avLst/>
-          </a:prstGeom>
-        </p:spPr>
-      </p:pic>
-      <p:pic>
-        <p:nvPicPr>
-          <p:cNvPr id="4214" name="Picture 4213" descr="arcelormittal_peer_processed.png"/>
-          <p:cNvPicPr>
-            <a:picLocks noChangeAspect="1"/>
-          </p:cNvPicPr>
-          <p:nvPr/>
-        </p:nvPicPr>
-        <p:blipFill>
-          <a:blip r:embed="rId9"/>
-          <a:stretch>
-            <a:fillRect/>
-          </a:stretch>
-        </p:blipFill>
-        <p:spPr>
-          <a:xfrm>
-            <a:off x="9904432" y="5173330"/>
-            <a:ext cx="327530" cy="168474"/>
-          </a:xfrm>
-          <a:prstGeom prst="rect">
-            <a:avLst/>
-          </a:prstGeom>
-        </p:spPr>
-      </p:pic>
-      <p:pic>
-        <p:nvPicPr>
-          <p:cNvPr id="4215" name="Picture 4214" descr="nucor_peer_processed.png"/>
-          <p:cNvPicPr>
-            <a:picLocks noChangeAspect="1"/>
-          </p:cNvPicPr>
-          <p:nvPr/>
-        </p:nvPicPr>
-        <p:blipFill>
-          <a:blip r:embed="rId11"/>
-          <a:stretch>
-            <a:fillRect/>
-          </a:stretch>
-        </p:blipFill>
-        <p:spPr>
-          <a:xfrm>
-            <a:off x="10236534" y="5173330"/>
-            <a:ext cx="256455" cy="168474"/>
-          </a:xfrm>
-          <a:prstGeom prst="rect">
-            <a:avLst/>
-          </a:prstGeom>
-        </p:spPr>
-      </p:pic>
-      <p:pic>
-        <p:nvPicPr>
-          <p:cNvPr id="4216" name="Picture 4215" descr="sidenor_peer_processed.png"/>
-          <p:cNvPicPr>
-            <a:picLocks noChangeAspect="1"/>
-          </p:cNvPicPr>
-          <p:nvPr/>
-        </p:nvPicPr>
-        <p:blipFill>
-          <a:blip r:embed="rId12"/>
-          <a:stretch>
-            <a:fillRect/>
-          </a:stretch>
-        </p:blipFill>
-        <p:spPr>
-          <a:xfrm>
-            <a:off x="10497560" y="5173330"/>
-            <a:ext cx="168474" cy="168474"/>
-          </a:xfrm>
-          <a:prstGeom prst="rect">
-            <a:avLst/>
-          </a:prstGeom>
-        </p:spPr>
-      </p:pic>
-      <p:pic>
-        <p:nvPicPr>
-          <p:cNvPr id="4217" name="Picture 4216" descr="megasa_peer_processed.png"/>
-          <p:cNvPicPr>
-            <a:picLocks noChangeAspect="1"/>
-          </p:cNvPicPr>
-          <p:nvPr/>
-        </p:nvPicPr>
-        <p:blipFill>
-          <a:blip r:embed="rId10"/>
-          <a:stretch>
-            <a:fillRect/>
-          </a:stretch>
-        </p:blipFill>
-        <p:spPr>
-          <a:xfrm>
-            <a:off x="8868779" y="5605221"/>
-            <a:ext cx="166662" cy="168474"/>
-          </a:xfrm>
-          <a:prstGeom prst="rect">
-            <a:avLst/>
-          </a:prstGeom>
-        </p:spPr>
-      </p:pic>
-      <p:pic>
-        <p:nvPicPr>
-          <p:cNvPr id="4218" name="Picture 4217" descr="nucor_peer_processed.png"/>
-          <p:cNvPicPr>
-            <a:picLocks noChangeAspect="1"/>
-          </p:cNvPicPr>
-          <p:nvPr/>
-        </p:nvPicPr>
-        <p:blipFill>
-          <a:blip r:embed="rId11"/>
-          <a:stretch>
-            <a:fillRect/>
-          </a:stretch>
-        </p:blipFill>
-        <p:spPr>
-          <a:xfrm>
-            <a:off x="9040013" y="5605221"/>
-            <a:ext cx="256455" cy="168474"/>
-          </a:xfrm>
-          <a:prstGeom prst="rect">
-            <a:avLst/>
-          </a:prstGeom>
-        </p:spPr>
-      </p:pic>
-      <p:pic>
-        <p:nvPicPr>
-          <p:cNvPr id="4219" name="Picture 4218" descr="client_logo_processed.png"/>
-          <p:cNvPicPr>
-            <a:picLocks noChangeAspect="1"/>
-          </p:cNvPicPr>
-          <p:nvPr/>
-        </p:nvPicPr>
-        <p:blipFill>
-          <a:blip r:embed="rId8"/>
-          <a:stretch>
-            <a:fillRect/>
-          </a:stretch>
-        </p:blipFill>
-        <p:spPr>
-          <a:xfrm>
-            <a:off x="9873386" y="5605221"/>
-            <a:ext cx="156987" cy="168474"/>
-          </a:xfrm>
-          <a:prstGeom prst="rect">
-            <a:avLst/>
-          </a:prstGeom>
-        </p:spPr>
-      </p:pic>
-      <p:pic>
-        <p:nvPicPr>
-          <p:cNvPr id="4220" name="Picture 4219" descr="arcelormittal_peer_processed.png"/>
-          <p:cNvPicPr>
-            <a:picLocks noChangeAspect="1"/>
-          </p:cNvPicPr>
-          <p:nvPr/>
-        </p:nvPicPr>
-        <p:blipFill>
-          <a:blip r:embed="rId9"/>
-          <a:stretch>
-            <a:fillRect/>
-          </a:stretch>
-        </p:blipFill>
-        <p:spPr>
-          <a:xfrm>
-            <a:off x="10034945" y="5605221"/>
-            <a:ext cx="327530" cy="168474"/>
-          </a:xfrm>
-          <a:prstGeom prst="rect">
-            <a:avLst/>
-          </a:prstGeom>
-        </p:spPr>
-      </p:pic>
-      <p:pic>
-        <p:nvPicPr>
-          <p:cNvPr id="4221" name="Picture 4220" descr="sidenor_peer_processed.png"/>
-          <p:cNvPicPr>
-            <a:picLocks noChangeAspect="1"/>
-          </p:cNvPicPr>
-          <p:nvPr/>
-        </p:nvPicPr>
-        <p:blipFill>
-          <a:blip r:embed="rId12"/>
-          <a:stretch>
-            <a:fillRect/>
-          </a:stretch>
-        </p:blipFill>
-        <p:spPr>
-          <a:xfrm>
-            <a:off x="10367047" y="5605221"/>
-            <a:ext cx="168474" cy="168474"/>
-          </a:xfrm>
-          <a:prstGeom prst="rect">
-            <a:avLst/>
-          </a:prstGeom>
-        </p:spPr>
-      </p:pic>
-      <p:pic>
-        <p:nvPicPr>
-          <p:cNvPr id="4222" name="Picture 4221" descr="client_logo_processed.png"/>
-          <p:cNvPicPr>
-            <a:picLocks noChangeAspect="1"/>
-          </p:cNvPicPr>
-          <p:nvPr/>
-        </p:nvPicPr>
-        <p:blipFill>
-          <a:blip r:embed="rId8"/>
-          <a:stretch>
-            <a:fillRect/>
-          </a:stretch>
-        </p:blipFill>
-        <p:spPr>
-          <a:xfrm>
-            <a:off x="9657256" y="6037112"/>
-            <a:ext cx="156987" cy="168474"/>
-          </a:xfrm>
-          <a:prstGeom prst="rect">
-            <a:avLst/>
-          </a:prstGeom>
-        </p:spPr>
-      </p:pic>
-      <p:pic>
-        <p:nvPicPr>
-          <p:cNvPr id="4223" name="Picture 4222" descr="arcelormittal_peer_processed.png"/>
-          <p:cNvPicPr>
-            <a:picLocks noChangeAspect="1"/>
-          </p:cNvPicPr>
-          <p:nvPr/>
-        </p:nvPicPr>
-        <p:blipFill>
-          <a:blip r:embed="rId9"/>
-          <a:stretch>
-            <a:fillRect/>
-          </a:stretch>
-        </p:blipFill>
-        <p:spPr>
-          <a:xfrm>
-            <a:off x="9818815" y="6037112"/>
-            <a:ext cx="327530" cy="168474"/>
-          </a:xfrm>
-          <a:prstGeom prst="rect">
-            <a:avLst/>
-          </a:prstGeom>
-        </p:spPr>
-      </p:pic>
-      <p:pic>
-        <p:nvPicPr>
-          <p:cNvPr id="4224" name="Picture 4223" descr="megasa_peer_processed.png"/>
-          <p:cNvPicPr>
-            <a:picLocks noChangeAspect="1"/>
-          </p:cNvPicPr>
-          <p:nvPr/>
-        </p:nvPicPr>
-        <p:blipFill>
-          <a:blip r:embed="rId10"/>
-          <a:stretch>
-            <a:fillRect/>
-          </a:stretch>
-        </p:blipFill>
-        <p:spPr>
-          <a:xfrm>
-            <a:off x="10150917" y="6037112"/>
-            <a:ext cx="166662" cy="168474"/>
-          </a:xfrm>
-          <a:prstGeom prst="rect">
-            <a:avLst/>
-          </a:prstGeom>
-        </p:spPr>
-      </p:pic>
-      <p:pic>
-        <p:nvPicPr>
-          <p:cNvPr id="4225" name="Picture 4224" descr="nucor_peer_processed.png"/>
-          <p:cNvPicPr>
-            <a:picLocks noChangeAspect="1"/>
-          </p:cNvPicPr>
-          <p:nvPr/>
-        </p:nvPicPr>
-        <p:blipFill>
-          <a:blip r:embed="rId11"/>
-          <a:stretch>
-            <a:fillRect/>
-          </a:stretch>
-        </p:blipFill>
-        <p:spPr>
-          <a:xfrm>
-            <a:off x="10322151" y="6037112"/>
-            <a:ext cx="256455" cy="168474"/>
-          </a:xfrm>
-          <a:prstGeom prst="rect">
-            <a:avLst/>
-          </a:prstGeom>
-        </p:spPr>
-      </p:pic>
-      <p:pic>
-        <p:nvPicPr>
-          <p:cNvPr id="4226" name="Picture 4225" descr="sidenor_peer_processed.png"/>
-          <p:cNvPicPr>
-            <a:picLocks noChangeAspect="1"/>
-          </p:cNvPicPr>
-          <p:nvPr/>
-        </p:nvPicPr>
-        <p:blipFill>
-          <a:blip r:embed="rId12"/>
-          <a:stretch>
-            <a:fillRect/>
-          </a:stretch>
-        </p:blipFill>
-        <p:spPr>
-          <a:xfrm>
-            <a:off x="10583177" y="6037112"/>
-            <a:ext cx="168474" cy="168474"/>
+            <a:off x="10415057" y="6033924"/>
+            <a:ext cx="335129" cy="174850"/>
           </a:xfrm>
           <a:prstGeom prst="rect">
             <a:avLst/>
@@ -22068,7 +22068,7 @@
             </a:r>
             <a:r>
               <a:rPr lang="en-US" err="1"/>
-              <a:t>Celsa</a:t>
+              <a:t>Legálitas</a:t>
             </a:r>
             <a:r>
               <a:rPr lang="en-US"/>
@@ -22504,8 +22504,8 @@
         </p:blipFill>
         <p:spPr>
           <a:xfrm>
-            <a:off x="5564104" y="925907"/>
-            <a:ext cx="200943" cy="215646"/>
+            <a:off x="5564104" y="921826"/>
+            <a:ext cx="428965" cy="223808"/>
           </a:xfrm>
           <a:prstGeom prst="rect">
             <a:avLst/>
@@ -22520,8 +22520,8 @@
         </p:nvSpPr>
         <p:spPr>
           <a:xfrm>
-            <a:off x="5819910" y="925907"/>
-            <a:ext cx="404864" cy="215646"/>
+            <a:off x="6047933" y="921826"/>
+            <a:ext cx="544864" cy="223808"/>
           </a:xfrm>
           <a:prstGeom prst="rect">
             <a:avLst/>
@@ -22537,14 +22537,14 @@
             <a:pPr algn="l"/>
             <a:r>
               <a:rPr sz="1000"/>
-              <a:t>Celsa</a:t>
+              <a:t>DZ Bank</a:t>
             </a:r>
           </a:p>
         </p:txBody>
       </p:sp>
       <p:pic>
         <p:nvPicPr>
-          <p:cNvPr id="559" name="Picture 558" descr="arcelormittal_peer_processed.png"/>
+          <p:cNvPr id="559" name="Picture 558" descr="bayerische_landesbank_peer_processed.png"/>
           <p:cNvPicPr>
             <a:picLocks noChangeAspect="1"/>
           </p:cNvPicPr>
@@ -22558,8 +22558,8 @@
         </p:blipFill>
         <p:spPr>
           <a:xfrm>
-            <a:off x="7192520" y="925907"/>
-            <a:ext cx="419237" cy="215646"/>
+            <a:off x="7192520" y="921826"/>
+            <a:ext cx="243440" cy="223808"/>
           </a:xfrm>
           <a:prstGeom prst="rect">
             <a:avLst/>
@@ -22574,8 +22574,8 @@
         </p:nvSpPr>
         <p:spPr>
           <a:xfrm>
-            <a:off x="7666621" y="925907"/>
-            <a:ext cx="964864" cy="215646"/>
+            <a:off x="7490824" y="921826"/>
+            <a:ext cx="1524864" cy="223808"/>
           </a:xfrm>
           <a:prstGeom prst="rect">
             <a:avLst/>
@@ -22591,14 +22591,14 @@
             <a:pPr algn="l"/>
             <a:r>
               <a:rPr sz="1000"/>
-              <a:t>ArcelorMittal</a:t>
+              <a:t>Bayerische Landesbank</a:t>
             </a:r>
           </a:p>
         </p:txBody>
       </p:sp>
       <p:pic>
         <p:nvPicPr>
-          <p:cNvPr id="561" name="Picture 560" descr="megasa_peer_processed.png"/>
+          <p:cNvPr id="561" name="Picture 560" descr="commerzbank_ag_peer_processed.png"/>
           <p:cNvPicPr>
             <a:picLocks noChangeAspect="1"/>
           </p:cNvPicPr>
@@ -22612,8 +22612,8 @@
         </p:blipFill>
         <p:spPr>
           <a:xfrm>
-            <a:off x="8777789" y="925907"/>
-            <a:ext cx="213327" cy="215646"/>
+            <a:off x="9161992" y="921826"/>
+            <a:ext cx="258623" cy="223808"/>
           </a:xfrm>
           <a:prstGeom prst="rect">
             <a:avLst/>
@@ -22628,8 +22628,8 @@
         </p:nvSpPr>
         <p:spPr>
           <a:xfrm>
-            <a:off x="9045980" y="925907"/>
-            <a:ext cx="474864" cy="215646"/>
+            <a:off x="9475478" y="921826"/>
+            <a:ext cx="1034864" cy="223808"/>
           </a:xfrm>
           <a:prstGeom prst="rect">
             <a:avLst/>
@@ -22645,14 +22645,14 @@
             <a:pPr algn="l"/>
             <a:r>
               <a:rPr sz="1000"/>
-              <a:t>Megasa</a:t>
+              <a:t>Commerzbank AG</a:t>
             </a:r>
           </a:p>
         </p:txBody>
       </p:sp>
       <p:pic>
         <p:nvPicPr>
-          <p:cNvPr id="563" name="Picture 562" descr="nucor_peer_processed.png"/>
+          <p:cNvPr id="563" name="Picture 562" descr="deutsche_bank_ag_peer_processed.png"/>
           <p:cNvPicPr>
             <a:picLocks noChangeAspect="1"/>
           </p:cNvPicPr>
@@ -22666,8 +22666,8 @@
         </p:blipFill>
         <p:spPr>
           <a:xfrm>
-            <a:off x="9667148" y="925907"/>
-            <a:ext cx="328261" cy="215646"/>
+            <a:off x="7192520" y="1218786"/>
+            <a:ext cx="218834" cy="223808"/>
           </a:xfrm>
           <a:prstGeom prst="rect">
             <a:avLst/>
@@ -22682,8 +22682,8 @@
         </p:nvSpPr>
         <p:spPr>
           <a:xfrm>
-            <a:off x="10050273" y="925907"/>
-            <a:ext cx="404864" cy="215646"/>
+            <a:off x="7466218" y="1218786"/>
+            <a:ext cx="1174864" cy="223808"/>
           </a:xfrm>
           <a:prstGeom prst="rect">
             <a:avLst/>
@@ -22699,14 +22699,14 @@
             <a:pPr algn="l"/>
             <a:r>
               <a:rPr sz="1000"/>
-              <a:t>Nucor</a:t>
+              <a:t>Deutsche Bank AG</a:t>
             </a:r>
           </a:p>
         </p:txBody>
       </p:sp>
       <p:pic>
         <p:nvPicPr>
-          <p:cNvPr id="565" name="Picture 564" descr="sidenor_peer_processed.png"/>
+          <p:cNvPr id="565" name="Picture 564" descr="volkswagen_financial_services_ag_peer_processed.png"/>
           <p:cNvPicPr>
             <a:picLocks noChangeAspect="1"/>
           </p:cNvPicPr>
@@ -22720,8 +22720,8 @@
         </p:blipFill>
         <p:spPr>
           <a:xfrm>
-            <a:off x="10601441" y="925907"/>
-            <a:ext cx="215646" cy="215646"/>
+            <a:off x="8787386" y="1218786"/>
+            <a:ext cx="223808" cy="223808"/>
           </a:xfrm>
           <a:prstGeom prst="rect">
             <a:avLst/>
@@ -22736,8 +22736,8 @@
         </p:nvSpPr>
         <p:spPr>
           <a:xfrm>
-            <a:off x="10871951" y="925907"/>
-            <a:ext cx="544864" cy="215646"/>
+            <a:off x="9066058" y="1218786"/>
+            <a:ext cx="2294864" cy="223808"/>
           </a:xfrm>
           <a:prstGeom prst="rect">
             <a:avLst/>
@@ -22753,14 +22753,110 @@
             <a:pPr algn="l"/>
             <a:r>
               <a:rPr sz="1000"/>
-              <a:t>Sidenor</a:t>
+              <a:t>Volkswagen Financial Services AG</a:t>
             </a:r>
           </a:p>
         </p:txBody>
       </p:sp>
       <p:pic>
         <p:nvPicPr>
-          <p:cNvPr id="567" name="Picture 566" descr="client_logo_processed.png"/>
+          <p:cNvPr id="567" name="Picture 566" descr="bayerische_landesbank_peer_processed.png"/>
+          <p:cNvPicPr>
+            <a:picLocks noChangeAspect="1"/>
+          </p:cNvPicPr>
+          <p:nvPr/>
+        </p:nvPicPr>
+        <p:blipFill>
+          <a:blip r:embed="rId8"/>
+          <a:stretch>
+            <a:fillRect/>
+          </a:stretch>
+        </p:blipFill>
+        <p:spPr>
+          <a:xfrm>
+            <a:off x="9632955" y="1691130"/>
+            <a:ext cx="190188" cy="174850"/>
+          </a:xfrm>
+          <a:prstGeom prst="rect">
+            <a:avLst/>
+          </a:prstGeom>
+        </p:spPr>
+      </p:pic>
+      <p:pic>
+        <p:nvPicPr>
+          <p:cNvPr id="568" name="Picture 567" descr="commerzbank_ag_peer_processed.png"/>
+          <p:cNvPicPr>
+            <a:picLocks noChangeAspect="1"/>
+          </p:cNvPicPr>
+          <p:nvPr/>
+        </p:nvPicPr>
+        <p:blipFill>
+          <a:blip r:embed="rId9"/>
+          <a:stretch>
+            <a:fillRect/>
+          </a:stretch>
+        </p:blipFill>
+        <p:spPr>
+          <a:xfrm>
+            <a:off x="9827714" y="1691130"/>
+            <a:ext cx="202049" cy="174850"/>
+          </a:xfrm>
+          <a:prstGeom prst="rect">
+            <a:avLst/>
+          </a:prstGeom>
+        </p:spPr>
+      </p:pic>
+      <p:pic>
+        <p:nvPicPr>
+          <p:cNvPr id="569" name="Picture 568" descr="deutsche_bank_ag_peer_processed.png"/>
+          <p:cNvPicPr>
+            <a:picLocks noChangeAspect="1"/>
+          </p:cNvPicPr>
+          <p:nvPr/>
+        </p:nvPicPr>
+        <p:blipFill>
+          <a:blip r:embed="rId10"/>
+          <a:stretch>
+            <a:fillRect/>
+          </a:stretch>
+        </p:blipFill>
+        <p:spPr>
+          <a:xfrm>
+            <a:off x="10034334" y="1691130"/>
+            <a:ext cx="170964" cy="174850"/>
+          </a:xfrm>
+          <a:prstGeom prst="rect">
+            <a:avLst/>
+          </a:prstGeom>
+        </p:spPr>
+      </p:pic>
+      <p:pic>
+        <p:nvPicPr>
+          <p:cNvPr id="570" name="Picture 569" descr="volkswagen_financial_services_ag_peer_processed.png"/>
+          <p:cNvPicPr>
+            <a:picLocks noChangeAspect="1"/>
+          </p:cNvPicPr>
+          <p:nvPr/>
+        </p:nvPicPr>
+        <p:blipFill>
+          <a:blip r:embed="rId11"/>
+          <a:stretch>
+            <a:fillRect/>
+          </a:stretch>
+        </p:blipFill>
+        <p:spPr>
+          <a:xfrm>
+            <a:off x="10209870" y="1691130"/>
+            <a:ext cx="174850" cy="174850"/>
+          </a:xfrm>
+          <a:prstGeom prst="rect">
+            <a:avLst/>
+          </a:prstGeom>
+        </p:spPr>
+      </p:pic>
+      <p:pic>
+        <p:nvPicPr>
+          <p:cNvPr id="571" name="Picture 570" descr="client_logo_processed.png"/>
           <p:cNvPicPr>
             <a:picLocks noChangeAspect="1"/>
           </p:cNvPicPr>
@@ -22774,8 +22870,8 @@
         </p:blipFill>
         <p:spPr>
           <a:xfrm>
-            <a:off x="8678640" y="1694318"/>
-            <a:ext cx="156987" cy="168474"/>
+            <a:off x="10389292" y="1691130"/>
+            <a:ext cx="335129" cy="174850"/>
           </a:xfrm>
           <a:prstGeom prst="rect">
             <a:avLst/>
@@ -22784,7 +22880,31 @@
       </p:pic>
       <p:pic>
         <p:nvPicPr>
-          <p:cNvPr id="568" name="Picture 567" descr="megasa_peer_processed.png"/>
+          <p:cNvPr id="572" name="Picture 571" descr="bayerische_landesbank_peer_processed.png"/>
+          <p:cNvPicPr>
+            <a:picLocks noChangeAspect="1"/>
+          </p:cNvPicPr>
+          <p:nvPr/>
+        </p:nvPicPr>
+        <p:blipFill>
+          <a:blip r:embed="rId8"/>
+          <a:stretch>
+            <a:fillRect/>
+          </a:stretch>
+        </p:blipFill>
+        <p:spPr>
+          <a:xfrm>
+            <a:off x="8964693" y="2082510"/>
+            <a:ext cx="190188" cy="174850"/>
+          </a:xfrm>
+          <a:prstGeom prst="rect">
+            <a:avLst/>
+          </a:prstGeom>
+        </p:spPr>
+      </p:pic>
+      <p:pic>
+        <p:nvPicPr>
+          <p:cNvPr id="573" name="Picture 572" descr="commerzbank_ag_peer_processed.png"/>
           <p:cNvPicPr>
             <a:picLocks noChangeAspect="1"/>
           </p:cNvPicPr>
@@ -22798,8 +22918,8 @@
         </p:blipFill>
         <p:spPr>
           <a:xfrm>
-            <a:off x="8840199" y="1694318"/>
-            <a:ext cx="166662" cy="168474"/>
+            <a:off x="9730334" y="2082510"/>
+            <a:ext cx="202049" cy="174850"/>
           </a:xfrm>
           <a:prstGeom prst="rect">
             <a:avLst/>
@@ -22808,7 +22928,7 @@
       </p:pic>
       <p:pic>
         <p:nvPicPr>
-          <p:cNvPr id="569" name="Picture 568" descr="nucor_peer_processed.png"/>
+          <p:cNvPr id="574" name="Picture 573" descr="deutsche_bank_ag_peer_processed.png"/>
           <p:cNvPicPr>
             <a:picLocks noChangeAspect="1"/>
           </p:cNvPicPr>
@@ -22822,8 +22942,8 @@
         </p:blipFill>
         <p:spPr>
           <a:xfrm>
-            <a:off x="9011433" y="1694318"/>
-            <a:ext cx="256455" cy="168474"/>
+            <a:off x="9936954" y="2082510"/>
+            <a:ext cx="170964" cy="174850"/>
           </a:xfrm>
           <a:prstGeom prst="rect">
             <a:avLst/>
@@ -22832,7 +22952,7 @@
       </p:pic>
       <p:pic>
         <p:nvPicPr>
-          <p:cNvPr id="570" name="Picture 569" descr="sidenor_peer_processed.png"/>
+          <p:cNvPr id="575" name="Picture 574" descr="volkswagen_financial_services_ag_peer_processed.png"/>
           <p:cNvPicPr>
             <a:picLocks noChangeAspect="1"/>
           </p:cNvPicPr>
@@ -22846,8 +22966,8 @@
         </p:blipFill>
         <p:spPr>
           <a:xfrm>
-            <a:off x="9272459" y="1694318"/>
-            <a:ext cx="168474" cy="168474"/>
+            <a:off x="10112490" y="2082510"/>
+            <a:ext cx="174850" cy="174850"/>
           </a:xfrm>
           <a:prstGeom prst="rect">
             <a:avLst/>
@@ -22856,7 +22976,31 @@
       </p:pic>
       <p:pic>
         <p:nvPicPr>
-          <p:cNvPr id="571" name="Picture 570" descr="arcelormittal_peer_processed.png"/>
+          <p:cNvPr id="576" name="Picture 575" descr="client_logo_processed.png"/>
+          <p:cNvPicPr>
+            <a:picLocks noChangeAspect="1"/>
+          </p:cNvPicPr>
+          <p:nvPr/>
+        </p:nvPicPr>
+        <p:blipFill>
+          <a:blip r:embed="rId7"/>
+          <a:stretch>
+            <a:fillRect/>
+          </a:stretch>
+        </p:blipFill>
+        <p:spPr>
+          <a:xfrm>
+            <a:off x="10291912" y="2082510"/>
+            <a:ext cx="335129" cy="174850"/>
+          </a:xfrm>
+          <a:prstGeom prst="rect">
+            <a:avLst/>
+          </a:prstGeom>
+        </p:spPr>
+      </p:pic>
+      <p:pic>
+        <p:nvPicPr>
+          <p:cNvPr id="577" name="Picture 576" descr="bayerische_landesbank_peer_processed.png"/>
           <p:cNvPicPr>
             <a:picLocks noChangeAspect="1"/>
           </p:cNvPicPr>
@@ -22870,8 +23014,8 @@
         </p:blipFill>
         <p:spPr>
           <a:xfrm>
-            <a:off x="10014923" y="1694318"/>
-            <a:ext cx="327530" cy="168474"/>
+            <a:off x="8794842" y="2475218"/>
+            <a:ext cx="190188" cy="174850"/>
           </a:xfrm>
           <a:prstGeom prst="rect">
             <a:avLst/>
@@ -22880,7 +23024,7 @@
       </p:pic>
       <p:pic>
         <p:nvPicPr>
-          <p:cNvPr id="572" name="Picture 571" descr="client_logo_processed.png"/>
+          <p:cNvPr id="578" name="Picture 577" descr="client_logo_processed.png"/>
           <p:cNvPicPr>
             <a:picLocks noChangeAspect="1"/>
           </p:cNvPicPr>
@@ -22894,8 +23038,8 @@
         </p:blipFill>
         <p:spPr>
           <a:xfrm>
-            <a:off x="8678640" y="2085698"/>
-            <a:ext cx="156987" cy="168474"/>
+            <a:off x="8989601" y="2475218"/>
+            <a:ext cx="335129" cy="174850"/>
           </a:xfrm>
           <a:prstGeom prst="rect">
             <a:avLst/>
@@ -22904,7 +23048,7 @@
       </p:pic>
       <p:pic>
         <p:nvPicPr>
-          <p:cNvPr id="573" name="Picture 572" descr="megasa_peer_processed.png"/>
+          <p:cNvPr id="579" name="Picture 578" descr="commerzbank_ag_peer_processed.png"/>
           <p:cNvPicPr>
             <a:picLocks noChangeAspect="1"/>
           </p:cNvPicPr>
@@ -22918,8 +23062,8 @@
         </p:blipFill>
         <p:spPr>
           <a:xfrm>
-            <a:off x="8840199" y="2085698"/>
-            <a:ext cx="166662" cy="168474"/>
+            <a:off x="9900185" y="2475218"/>
+            <a:ext cx="202049" cy="174850"/>
           </a:xfrm>
           <a:prstGeom prst="rect">
             <a:avLst/>
@@ -22928,7 +23072,7 @@
       </p:pic>
       <p:pic>
         <p:nvPicPr>
-          <p:cNvPr id="574" name="Picture 573" descr="nucor_peer_processed.png"/>
+          <p:cNvPr id="580" name="Picture 579" descr="deutsche_bank_ag_peer_processed.png"/>
           <p:cNvPicPr>
             <a:picLocks noChangeAspect="1"/>
           </p:cNvPicPr>
@@ -22942,8 +23086,8 @@
         </p:blipFill>
         <p:spPr>
           <a:xfrm>
-            <a:off x="9011433" y="2085698"/>
-            <a:ext cx="256455" cy="168474"/>
+            <a:off x="10106805" y="2475218"/>
+            <a:ext cx="170964" cy="174850"/>
           </a:xfrm>
           <a:prstGeom prst="rect">
             <a:avLst/>
@@ -22952,7 +23096,7 @@
       </p:pic>
       <p:pic>
         <p:nvPicPr>
-          <p:cNvPr id="575" name="Picture 574" descr="sidenor_peer_processed.png"/>
+          <p:cNvPr id="581" name="Picture 580" descr="volkswagen_financial_services_ag_peer_processed.png"/>
           <p:cNvPicPr>
             <a:picLocks noChangeAspect="1"/>
           </p:cNvPicPr>
@@ -22966,8 +23110,8 @@
         </p:blipFill>
         <p:spPr>
           <a:xfrm>
-            <a:off x="9272459" y="2085698"/>
-            <a:ext cx="168474" cy="168474"/>
+            <a:off x="10282341" y="2475218"/>
+            <a:ext cx="174850" cy="174850"/>
           </a:xfrm>
           <a:prstGeom prst="rect">
             <a:avLst/>
@@ -22976,7 +23120,7 @@
       </p:pic>
       <p:pic>
         <p:nvPicPr>
-          <p:cNvPr id="576" name="Picture 575" descr="arcelormittal_peer_processed.png"/>
+          <p:cNvPr id="582" name="Picture 581" descr="bayerische_landesbank_peer_processed.png"/>
           <p:cNvPicPr>
             <a:picLocks noChangeAspect="1"/>
           </p:cNvPicPr>
@@ -22990,8 +23134,8 @@
         </p:blipFill>
         <p:spPr>
           <a:xfrm>
-            <a:off x="10014923" y="2085698"/>
-            <a:ext cx="327530" cy="168474"/>
+            <a:off x="8964693" y="2867926"/>
+            <a:ext cx="190188" cy="174850"/>
           </a:xfrm>
           <a:prstGeom prst="rect">
             <a:avLst/>
@@ -23000,7 +23144,79 @@
       </p:pic>
       <p:pic>
         <p:nvPicPr>
-          <p:cNvPr id="577" name="Picture 576" descr="client_logo_processed.png"/>
+          <p:cNvPr id="583" name="Picture 582" descr="commerzbank_ag_peer_processed.png"/>
+          <p:cNvPicPr>
+            <a:picLocks noChangeAspect="1"/>
+          </p:cNvPicPr>
+          <p:nvPr/>
+        </p:nvPicPr>
+        <p:blipFill>
+          <a:blip r:embed="rId9"/>
+          <a:stretch>
+            <a:fillRect/>
+          </a:stretch>
+        </p:blipFill>
+        <p:spPr>
+          <a:xfrm>
+            <a:off x="9730334" y="2867926"/>
+            <a:ext cx="202049" cy="174850"/>
+          </a:xfrm>
+          <a:prstGeom prst="rect">
+            <a:avLst/>
+          </a:prstGeom>
+        </p:spPr>
+      </p:pic>
+      <p:pic>
+        <p:nvPicPr>
+          <p:cNvPr id="584" name="Picture 583" descr="deutsche_bank_ag_peer_processed.png"/>
+          <p:cNvPicPr>
+            <a:picLocks noChangeAspect="1"/>
+          </p:cNvPicPr>
+          <p:nvPr/>
+        </p:nvPicPr>
+        <p:blipFill>
+          <a:blip r:embed="rId10"/>
+          <a:stretch>
+            <a:fillRect/>
+          </a:stretch>
+        </p:blipFill>
+        <p:spPr>
+          <a:xfrm>
+            <a:off x="9936954" y="2867926"/>
+            <a:ext cx="170964" cy="174850"/>
+          </a:xfrm>
+          <a:prstGeom prst="rect">
+            <a:avLst/>
+          </a:prstGeom>
+        </p:spPr>
+      </p:pic>
+      <p:pic>
+        <p:nvPicPr>
+          <p:cNvPr id="585" name="Picture 584" descr="volkswagen_financial_services_ag_peer_processed.png"/>
+          <p:cNvPicPr>
+            <a:picLocks noChangeAspect="1"/>
+          </p:cNvPicPr>
+          <p:nvPr/>
+        </p:nvPicPr>
+        <p:blipFill>
+          <a:blip r:embed="rId11"/>
+          <a:stretch>
+            <a:fillRect/>
+          </a:stretch>
+        </p:blipFill>
+        <p:spPr>
+          <a:xfrm>
+            <a:off x="10112490" y="2867926"/>
+            <a:ext cx="174850" cy="174850"/>
+          </a:xfrm>
+          <a:prstGeom prst="rect">
+            <a:avLst/>
+          </a:prstGeom>
+        </p:spPr>
+      </p:pic>
+      <p:pic>
+        <p:nvPicPr>
+          <p:cNvPr id="586" name="Picture 585" descr="client_logo_processed.png"/>
           <p:cNvPicPr>
             <a:picLocks noChangeAspect="1"/>
           </p:cNvPicPr>
@@ -23014,8 +23230,8 @@
         </p:blipFill>
         <p:spPr>
           <a:xfrm>
-            <a:off x="8678640" y="2478406"/>
-            <a:ext cx="156987" cy="168474"/>
+            <a:off x="10291912" y="2867926"/>
+            <a:ext cx="335129" cy="174850"/>
           </a:xfrm>
           <a:prstGeom prst="rect">
             <a:avLst/>
@@ -23024,7 +23240,31 @@
       </p:pic>
       <p:pic>
         <p:nvPicPr>
-          <p:cNvPr id="578" name="Picture 577" descr="megasa_peer_processed.png"/>
+          <p:cNvPr id="587" name="Picture 586" descr="bayerische_landesbank_peer_processed.png"/>
+          <p:cNvPicPr>
+            <a:picLocks noChangeAspect="1"/>
+          </p:cNvPicPr>
+          <p:nvPr/>
+        </p:nvPicPr>
+        <p:blipFill>
+          <a:blip r:embed="rId8"/>
+          <a:stretch>
+            <a:fillRect/>
+          </a:stretch>
+        </p:blipFill>
+        <p:spPr>
+          <a:xfrm>
+            <a:off x="9632955" y="3260634"/>
+            <a:ext cx="190188" cy="174850"/>
+          </a:xfrm>
+          <a:prstGeom prst="rect">
+            <a:avLst/>
+          </a:prstGeom>
+        </p:spPr>
+      </p:pic>
+      <p:pic>
+        <p:nvPicPr>
+          <p:cNvPr id="588" name="Picture 587" descr="commerzbank_ag_peer_processed.png"/>
           <p:cNvPicPr>
             <a:picLocks noChangeAspect="1"/>
           </p:cNvPicPr>
@@ -23038,8 +23278,8 @@
         </p:blipFill>
         <p:spPr>
           <a:xfrm>
-            <a:off x="8840199" y="2478406"/>
-            <a:ext cx="166662" cy="168474"/>
+            <a:off x="9827714" y="3260634"/>
+            <a:ext cx="202049" cy="174850"/>
           </a:xfrm>
           <a:prstGeom prst="rect">
             <a:avLst/>
@@ -23048,7 +23288,7 @@
       </p:pic>
       <p:pic>
         <p:nvPicPr>
-          <p:cNvPr id="579" name="Picture 578" descr="nucor_peer_processed.png"/>
+          <p:cNvPr id="589" name="Picture 588" descr="deutsche_bank_ag_peer_processed.png"/>
           <p:cNvPicPr>
             <a:picLocks noChangeAspect="1"/>
           </p:cNvPicPr>
@@ -23062,8 +23302,8 @@
         </p:blipFill>
         <p:spPr>
           <a:xfrm>
-            <a:off x="9011433" y="2478406"/>
-            <a:ext cx="256455" cy="168474"/>
+            <a:off x="10034334" y="3260634"/>
+            <a:ext cx="170964" cy="174850"/>
           </a:xfrm>
           <a:prstGeom prst="rect">
             <a:avLst/>
@@ -23072,7 +23312,7 @@
       </p:pic>
       <p:pic>
         <p:nvPicPr>
-          <p:cNvPr id="580" name="Picture 579" descr="sidenor_peer_processed.png"/>
+          <p:cNvPr id="590" name="Picture 589" descr="volkswagen_financial_services_ag_peer_processed.png"/>
           <p:cNvPicPr>
             <a:picLocks noChangeAspect="1"/>
           </p:cNvPicPr>
@@ -23086,8 +23326,8 @@
         </p:blipFill>
         <p:spPr>
           <a:xfrm>
-            <a:off x="9272459" y="2478406"/>
-            <a:ext cx="168474" cy="168474"/>
+            <a:off x="10209870" y="3260634"/>
+            <a:ext cx="174850" cy="174850"/>
           </a:xfrm>
           <a:prstGeom prst="rect">
             <a:avLst/>
@@ -23096,7 +23336,31 @@
       </p:pic>
       <p:pic>
         <p:nvPicPr>
-          <p:cNvPr id="581" name="Picture 580" descr="arcelormittal_peer_processed.png"/>
+          <p:cNvPr id="591" name="Picture 590" descr="client_logo_processed.png"/>
+          <p:cNvPicPr>
+            <a:picLocks noChangeAspect="1"/>
+          </p:cNvPicPr>
+          <p:nvPr/>
+        </p:nvPicPr>
+        <p:blipFill>
+          <a:blip r:embed="rId7"/>
+          <a:stretch>
+            <a:fillRect/>
+          </a:stretch>
+        </p:blipFill>
+        <p:spPr>
+          <a:xfrm>
+            <a:off x="10389292" y="3260634"/>
+            <a:ext cx="335129" cy="174850"/>
+          </a:xfrm>
+          <a:prstGeom prst="rect">
+            <a:avLst/>
+          </a:prstGeom>
+        </p:spPr>
+      </p:pic>
+      <p:pic>
+        <p:nvPicPr>
+          <p:cNvPr id="592" name="Picture 591" descr="bayerische_landesbank_peer_processed.png"/>
           <p:cNvPicPr>
             <a:picLocks noChangeAspect="1"/>
           </p:cNvPicPr>
@@ -23110,8 +23374,8 @@
         </p:blipFill>
         <p:spPr>
           <a:xfrm>
-            <a:off x="10014923" y="2478406"/>
-            <a:ext cx="327530" cy="168474"/>
+            <a:off x="9802805" y="3653342"/>
+            <a:ext cx="190188" cy="174850"/>
           </a:xfrm>
           <a:prstGeom prst="rect">
             <a:avLst/>
@@ -23120,7 +23384,7 @@
       </p:pic>
       <p:pic>
         <p:nvPicPr>
-          <p:cNvPr id="582" name="Picture 581" descr="megasa_peer_processed.png"/>
+          <p:cNvPr id="593" name="Picture 592" descr="commerzbank_ag_peer_processed.png"/>
           <p:cNvPicPr>
             <a:picLocks noChangeAspect="1"/>
           </p:cNvPicPr>
@@ -23134,8 +23398,8 @@
         </p:blipFill>
         <p:spPr>
           <a:xfrm>
-            <a:off x="8976455" y="2871114"/>
-            <a:ext cx="166662" cy="168474"/>
+            <a:off x="9997564" y="3653342"/>
+            <a:ext cx="202049" cy="174850"/>
           </a:xfrm>
           <a:prstGeom prst="rect">
             <a:avLst/>
@@ -23144,7 +23408,55 @@
       </p:pic>
       <p:pic>
         <p:nvPicPr>
-          <p:cNvPr id="583" name="Picture 582" descr="client_logo_processed.png"/>
+          <p:cNvPr id="594" name="Picture 593" descr="deutsche_bank_ag_peer_processed.png"/>
+          <p:cNvPicPr>
+            <a:picLocks noChangeAspect="1"/>
+          </p:cNvPicPr>
+          <p:nvPr/>
+        </p:nvPicPr>
+        <p:blipFill>
+          <a:blip r:embed="rId10"/>
+          <a:stretch>
+            <a:fillRect/>
+          </a:stretch>
+        </p:blipFill>
+        <p:spPr>
+          <a:xfrm>
+            <a:off x="10204184" y="3653342"/>
+            <a:ext cx="170964" cy="174850"/>
+          </a:xfrm>
+          <a:prstGeom prst="rect">
+            <a:avLst/>
+          </a:prstGeom>
+        </p:spPr>
+      </p:pic>
+      <p:pic>
+        <p:nvPicPr>
+          <p:cNvPr id="595" name="Picture 594" descr="volkswagen_financial_services_ag_peer_processed.png"/>
+          <p:cNvPicPr>
+            <a:picLocks noChangeAspect="1"/>
+          </p:cNvPicPr>
+          <p:nvPr/>
+        </p:nvPicPr>
+        <p:blipFill>
+          <a:blip r:embed="rId11"/>
+          <a:stretch>
+            <a:fillRect/>
+          </a:stretch>
+        </p:blipFill>
+        <p:spPr>
+          <a:xfrm>
+            <a:off x="10379720" y="3653342"/>
+            <a:ext cx="174850" cy="174850"/>
+          </a:xfrm>
+          <a:prstGeom prst="rect">
+            <a:avLst/>
+          </a:prstGeom>
+        </p:spPr>
+      </p:pic>
+      <p:pic>
+        <p:nvPicPr>
+          <p:cNvPr id="596" name="Picture 595" descr="client_logo_processed.png"/>
           <p:cNvPicPr>
             <a:picLocks noChangeAspect="1"/>
           </p:cNvPicPr>
@@ -23158,8 +23470,8 @@
         </p:blipFill>
         <p:spPr>
           <a:xfrm>
-            <a:off x="9717107" y="2871114"/>
-            <a:ext cx="156987" cy="168474"/>
+            <a:off x="11130025" y="3653342"/>
+            <a:ext cx="335129" cy="174850"/>
           </a:xfrm>
           <a:prstGeom prst="rect">
             <a:avLst/>
@@ -23168,7 +23480,7 @@
       </p:pic>
       <p:pic>
         <p:nvPicPr>
-          <p:cNvPr id="584" name="Picture 583" descr="arcelormittal_peer_processed.png"/>
+          <p:cNvPr id="597" name="Picture 596" descr="bayerische_landesbank_peer_processed.png"/>
           <p:cNvPicPr>
             <a:picLocks noChangeAspect="1"/>
           </p:cNvPicPr>
@@ -23182,8 +23494,8 @@
         </p:blipFill>
         <p:spPr>
           <a:xfrm>
-            <a:off x="9878666" y="2871114"/>
-            <a:ext cx="327530" cy="168474"/>
+            <a:off x="8964693" y="4044721"/>
+            <a:ext cx="190188" cy="174850"/>
           </a:xfrm>
           <a:prstGeom prst="rect">
             <a:avLst/>
@@ -23192,7 +23504,31 @@
       </p:pic>
       <p:pic>
         <p:nvPicPr>
-          <p:cNvPr id="585" name="Picture 584" descr="nucor_peer_processed.png"/>
+          <p:cNvPr id="598" name="Picture 597" descr="commerzbank_ag_peer_processed.png"/>
+          <p:cNvPicPr>
+            <a:picLocks noChangeAspect="1"/>
+          </p:cNvPicPr>
+          <p:nvPr/>
+        </p:nvPicPr>
+        <p:blipFill>
+          <a:blip r:embed="rId9"/>
+          <a:stretch>
+            <a:fillRect/>
+          </a:stretch>
+        </p:blipFill>
+        <p:spPr>
+          <a:xfrm>
+            <a:off x="9730334" y="4044721"/>
+            <a:ext cx="202049" cy="174850"/>
+          </a:xfrm>
+          <a:prstGeom prst="rect">
+            <a:avLst/>
+          </a:prstGeom>
+        </p:spPr>
+      </p:pic>
+      <p:pic>
+        <p:nvPicPr>
+          <p:cNvPr id="599" name="Picture 598" descr="deutsche_bank_ag_peer_processed.png"/>
           <p:cNvPicPr>
             <a:picLocks noChangeAspect="1"/>
           </p:cNvPicPr>
@@ -23206,8 +23542,8 @@
         </p:blipFill>
         <p:spPr>
           <a:xfrm>
-            <a:off x="10210768" y="2871114"/>
-            <a:ext cx="256455" cy="168474"/>
+            <a:off x="9936954" y="4044721"/>
+            <a:ext cx="170964" cy="174850"/>
           </a:xfrm>
           <a:prstGeom prst="rect">
             <a:avLst/>
@@ -23216,7 +23552,7 @@
       </p:pic>
       <p:pic>
         <p:nvPicPr>
-          <p:cNvPr id="586" name="Picture 585" descr="sidenor_peer_processed.png"/>
+          <p:cNvPr id="600" name="Picture 599" descr="volkswagen_financial_services_ag_peer_processed.png"/>
           <p:cNvPicPr>
             <a:picLocks noChangeAspect="1"/>
           </p:cNvPicPr>
@@ -23230,8 +23566,8 @@
         </p:blipFill>
         <p:spPr>
           <a:xfrm>
-            <a:off x="10471794" y="2871114"/>
-            <a:ext cx="168474" cy="168474"/>
+            <a:off x="10112490" y="4044721"/>
+            <a:ext cx="174850" cy="174850"/>
           </a:xfrm>
           <a:prstGeom prst="rect">
             <a:avLst/>
@@ -23240,7 +23576,55 @@
       </p:pic>
       <p:pic>
         <p:nvPicPr>
-          <p:cNvPr id="587" name="Picture 586" descr="megasa_peer_processed.png"/>
+          <p:cNvPr id="601" name="Picture 600" descr="client_logo_processed.png"/>
+          <p:cNvPicPr>
+            <a:picLocks noChangeAspect="1"/>
+          </p:cNvPicPr>
+          <p:nvPr/>
+        </p:nvPicPr>
+        <p:blipFill>
+          <a:blip r:embed="rId7"/>
+          <a:stretch>
+            <a:fillRect/>
+          </a:stretch>
+        </p:blipFill>
+        <p:spPr>
+          <a:xfrm>
+            <a:off x="10291912" y="4044721"/>
+            <a:ext cx="335129" cy="174850"/>
+          </a:xfrm>
+          <a:prstGeom prst="rect">
+            <a:avLst/>
+          </a:prstGeom>
+        </p:spPr>
+      </p:pic>
+      <p:pic>
+        <p:nvPicPr>
+          <p:cNvPr id="602" name="Picture 601" descr="bayerische_landesbank_peer_processed.png"/>
+          <p:cNvPicPr>
+            <a:picLocks noChangeAspect="1"/>
+          </p:cNvPicPr>
+          <p:nvPr/>
+        </p:nvPicPr>
+        <p:blipFill>
+          <a:blip r:embed="rId8"/>
+          <a:stretch>
+            <a:fillRect/>
+          </a:stretch>
+        </p:blipFill>
+        <p:spPr>
+          <a:xfrm>
+            <a:off x="9632955" y="4437942"/>
+            <a:ext cx="190188" cy="174850"/>
+          </a:xfrm>
+          <a:prstGeom prst="rect">
+            <a:avLst/>
+          </a:prstGeom>
+        </p:spPr>
+      </p:pic>
+      <p:pic>
+        <p:nvPicPr>
+          <p:cNvPr id="603" name="Picture 602" descr="commerzbank_ag_peer_processed.png"/>
           <p:cNvPicPr>
             <a:picLocks noChangeAspect="1"/>
           </p:cNvPicPr>
@@ -23254,8 +23638,8 @@
         </p:blipFill>
         <p:spPr>
           <a:xfrm>
-            <a:off x="8845942" y="3263822"/>
-            <a:ext cx="166662" cy="168474"/>
+            <a:off x="9827714" y="4437942"/>
+            <a:ext cx="202049" cy="174850"/>
           </a:xfrm>
           <a:prstGeom prst="rect">
             <a:avLst/>
@@ -23264,7 +23648,7 @@
       </p:pic>
       <p:pic>
         <p:nvPicPr>
-          <p:cNvPr id="588" name="Picture 587" descr="nucor_peer_processed.png"/>
+          <p:cNvPr id="604" name="Picture 603" descr="deutsche_bank_ag_peer_processed.png"/>
           <p:cNvPicPr>
             <a:picLocks noChangeAspect="1"/>
           </p:cNvPicPr>
@@ -23278,8 +23662,8 @@
         </p:blipFill>
         <p:spPr>
           <a:xfrm>
-            <a:off x="9017176" y="3263822"/>
-            <a:ext cx="256455" cy="168474"/>
+            <a:off x="10034334" y="4437942"/>
+            <a:ext cx="170964" cy="174850"/>
           </a:xfrm>
           <a:prstGeom prst="rect">
             <a:avLst/>
@@ -23288,7 +23672,31 @@
       </p:pic>
       <p:pic>
         <p:nvPicPr>
-          <p:cNvPr id="589" name="Picture 588" descr="client_logo_processed.png"/>
+          <p:cNvPr id="605" name="Picture 604" descr="volkswagen_financial_services_ag_peer_processed.png"/>
+          <p:cNvPicPr>
+            <a:picLocks noChangeAspect="1"/>
+          </p:cNvPicPr>
+          <p:nvPr/>
+        </p:nvPicPr>
+        <p:blipFill>
+          <a:blip r:embed="rId11"/>
+          <a:stretch>
+            <a:fillRect/>
+          </a:stretch>
+        </p:blipFill>
+        <p:spPr>
+          <a:xfrm>
+            <a:off x="10209870" y="4437942"/>
+            <a:ext cx="174850" cy="174850"/>
+          </a:xfrm>
+          <a:prstGeom prst="rect">
+            <a:avLst/>
+          </a:prstGeom>
+        </p:spPr>
+      </p:pic>
+      <p:pic>
+        <p:nvPicPr>
+          <p:cNvPr id="606" name="Picture 605" descr="client_logo_processed.png"/>
           <p:cNvPicPr>
             <a:picLocks noChangeAspect="1"/>
           </p:cNvPicPr>
@@ -23302,8 +23710,8 @@
         </p:blipFill>
         <p:spPr>
           <a:xfrm>
-            <a:off x="9847620" y="3263822"/>
-            <a:ext cx="156987" cy="168474"/>
+            <a:off x="10389292" y="4437942"/>
+            <a:ext cx="335129" cy="174850"/>
           </a:xfrm>
           <a:prstGeom prst="rect">
             <a:avLst/>
@@ -23312,7 +23720,7 @@
       </p:pic>
       <p:pic>
         <p:nvPicPr>
-          <p:cNvPr id="590" name="Picture 589" descr="arcelormittal_peer_processed.png"/>
+          <p:cNvPr id="607" name="Picture 606" descr="bayerische_landesbank_peer_processed.png"/>
           <p:cNvPicPr>
             <a:picLocks noChangeAspect="1"/>
           </p:cNvPicPr>
@@ -23326,8 +23734,8 @@
         </p:blipFill>
         <p:spPr>
           <a:xfrm>
-            <a:off x="10009179" y="3263822"/>
-            <a:ext cx="327530" cy="168474"/>
+            <a:off x="9632955" y="4832492"/>
+            <a:ext cx="190188" cy="174850"/>
           </a:xfrm>
           <a:prstGeom prst="rect">
             <a:avLst/>
@@ -23336,7 +23744,55 @@
       </p:pic>
       <p:pic>
         <p:nvPicPr>
-          <p:cNvPr id="591" name="Picture 590" descr="sidenor_peer_processed.png"/>
+          <p:cNvPr id="608" name="Picture 607" descr="commerzbank_ag_peer_processed.png"/>
+          <p:cNvPicPr>
+            <a:picLocks noChangeAspect="1"/>
+          </p:cNvPicPr>
+          <p:nvPr/>
+        </p:nvPicPr>
+        <p:blipFill>
+          <a:blip r:embed="rId9"/>
+          <a:stretch>
+            <a:fillRect/>
+          </a:stretch>
+        </p:blipFill>
+        <p:spPr>
+          <a:xfrm>
+            <a:off x="9827714" y="4832492"/>
+            <a:ext cx="202049" cy="174850"/>
+          </a:xfrm>
+          <a:prstGeom prst="rect">
+            <a:avLst/>
+          </a:prstGeom>
+        </p:spPr>
+      </p:pic>
+      <p:pic>
+        <p:nvPicPr>
+          <p:cNvPr id="609" name="Picture 608" descr="deutsche_bank_ag_peer_processed.png"/>
+          <p:cNvPicPr>
+            <a:picLocks noChangeAspect="1"/>
+          </p:cNvPicPr>
+          <p:nvPr/>
+        </p:nvPicPr>
+        <p:blipFill>
+          <a:blip r:embed="rId10"/>
+          <a:stretch>
+            <a:fillRect/>
+          </a:stretch>
+        </p:blipFill>
+        <p:spPr>
+          <a:xfrm>
+            <a:off x="10034334" y="4832492"/>
+            <a:ext cx="170964" cy="174850"/>
+          </a:xfrm>
+          <a:prstGeom prst="rect">
+            <a:avLst/>
+          </a:prstGeom>
+        </p:spPr>
+      </p:pic>
+      <p:pic>
+        <p:nvPicPr>
+          <p:cNvPr id="610" name="Picture 609" descr="volkswagen_financial_services_ag_peer_processed.png"/>
           <p:cNvPicPr>
             <a:picLocks noChangeAspect="1"/>
           </p:cNvPicPr>
@@ -23350,8 +23806,8 @@
         </p:blipFill>
         <p:spPr>
           <a:xfrm>
-            <a:off x="10341281" y="3263822"/>
-            <a:ext cx="168474" cy="168474"/>
+            <a:off x="10209870" y="4832492"/>
+            <a:ext cx="174850" cy="174850"/>
           </a:xfrm>
           <a:prstGeom prst="rect">
             <a:avLst/>
@@ -23360,7 +23816,55 @@
       </p:pic>
       <p:pic>
         <p:nvPicPr>
-          <p:cNvPr id="592" name="Picture 591" descr="megasa_peer_processed.png"/>
+          <p:cNvPr id="611" name="Picture 610" descr="client_logo_processed.png"/>
+          <p:cNvPicPr>
+            <a:picLocks noChangeAspect="1"/>
+          </p:cNvPicPr>
+          <p:nvPr/>
+        </p:nvPicPr>
+        <p:blipFill>
+          <a:blip r:embed="rId7"/>
+          <a:stretch>
+            <a:fillRect/>
+          </a:stretch>
+        </p:blipFill>
+        <p:spPr>
+          <a:xfrm>
+            <a:off x="10389292" y="4832492"/>
+            <a:ext cx="335129" cy="174850"/>
+          </a:xfrm>
+          <a:prstGeom prst="rect">
+            <a:avLst/>
+          </a:prstGeom>
+        </p:spPr>
+      </p:pic>
+      <p:pic>
+        <p:nvPicPr>
+          <p:cNvPr id="612" name="Picture 611" descr="bayerische_landesbank_peer_processed.png"/>
+          <p:cNvPicPr>
+            <a:picLocks noChangeAspect="1"/>
+          </p:cNvPicPr>
+          <p:nvPr/>
+        </p:nvPicPr>
+        <p:blipFill>
+          <a:blip r:embed="rId8"/>
+          <a:stretch>
+            <a:fillRect/>
+          </a:stretch>
+        </p:blipFill>
+        <p:spPr>
+          <a:xfrm>
+            <a:off x="9632955" y="5225200"/>
+            <a:ext cx="190188" cy="174850"/>
+          </a:xfrm>
+          <a:prstGeom prst="rect">
+            <a:avLst/>
+          </a:prstGeom>
+        </p:spPr>
+      </p:pic>
+      <p:pic>
+        <p:nvPicPr>
+          <p:cNvPr id="613" name="Picture 612" descr="commerzbank_ag_peer_processed.png"/>
           <p:cNvPicPr>
             <a:picLocks noChangeAspect="1"/>
           </p:cNvPicPr>
@@ -23374,8 +23878,8 @@
         </p:blipFill>
         <p:spPr>
           <a:xfrm>
-            <a:off x="8976455" y="3656530"/>
-            <a:ext cx="166662" cy="168474"/>
+            <a:off x="9827714" y="5225200"/>
+            <a:ext cx="202049" cy="174850"/>
           </a:xfrm>
           <a:prstGeom prst="rect">
             <a:avLst/>
@@ -23384,7 +23888,55 @@
       </p:pic>
       <p:pic>
         <p:nvPicPr>
-          <p:cNvPr id="593" name="Picture 592" descr="client_logo_processed.png"/>
+          <p:cNvPr id="614" name="Picture 613" descr="deutsche_bank_ag_peer_processed.png"/>
+          <p:cNvPicPr>
+            <a:picLocks noChangeAspect="1"/>
+          </p:cNvPicPr>
+          <p:nvPr/>
+        </p:nvPicPr>
+        <p:blipFill>
+          <a:blip r:embed="rId10"/>
+          <a:stretch>
+            <a:fillRect/>
+          </a:stretch>
+        </p:blipFill>
+        <p:spPr>
+          <a:xfrm>
+            <a:off x="10034334" y="5225200"/>
+            <a:ext cx="170964" cy="174850"/>
+          </a:xfrm>
+          <a:prstGeom prst="rect">
+            <a:avLst/>
+          </a:prstGeom>
+        </p:spPr>
+      </p:pic>
+      <p:pic>
+        <p:nvPicPr>
+          <p:cNvPr id="615" name="Picture 614" descr="volkswagen_financial_services_ag_peer_processed.png"/>
+          <p:cNvPicPr>
+            <a:picLocks noChangeAspect="1"/>
+          </p:cNvPicPr>
+          <p:nvPr/>
+        </p:nvPicPr>
+        <p:blipFill>
+          <a:blip r:embed="rId11"/>
+          <a:stretch>
+            <a:fillRect/>
+          </a:stretch>
+        </p:blipFill>
+        <p:spPr>
+          <a:xfrm>
+            <a:off x="10209870" y="5225200"/>
+            <a:ext cx="174850" cy="174850"/>
+          </a:xfrm>
+          <a:prstGeom prst="rect">
+            <a:avLst/>
+          </a:prstGeom>
+        </p:spPr>
+      </p:pic>
+      <p:pic>
+        <p:nvPicPr>
+          <p:cNvPr id="616" name="Picture 615" descr="client_logo_processed.png"/>
           <p:cNvPicPr>
             <a:picLocks noChangeAspect="1"/>
           </p:cNvPicPr>
@@ -23398,8 +23950,8 @@
         </p:blipFill>
         <p:spPr>
           <a:xfrm>
-            <a:off x="9717107" y="3656530"/>
-            <a:ext cx="156987" cy="168474"/>
+            <a:off x="10389292" y="5225200"/>
+            <a:ext cx="335129" cy="174850"/>
           </a:xfrm>
           <a:prstGeom prst="rect">
             <a:avLst/>
@@ -23408,7 +23960,7 @@
       </p:pic>
       <p:pic>
         <p:nvPicPr>
-          <p:cNvPr id="594" name="Picture 593" descr="arcelormittal_peer_processed.png"/>
+          <p:cNvPr id="617" name="Picture 616" descr="bayerische_landesbank_peer_processed.png"/>
           <p:cNvPicPr>
             <a:picLocks noChangeAspect="1"/>
           </p:cNvPicPr>
@@ -23422,8 +23974,8 @@
         </p:blipFill>
         <p:spPr>
           <a:xfrm>
-            <a:off x="9878666" y="3656530"/>
-            <a:ext cx="327530" cy="168474"/>
+            <a:off x="9824033" y="5617908"/>
+            <a:ext cx="190188" cy="174850"/>
           </a:xfrm>
           <a:prstGeom prst="rect">
             <a:avLst/>
@@ -23432,7 +23984,79 @@
       </p:pic>
       <p:pic>
         <p:nvPicPr>
-          <p:cNvPr id="595" name="Picture 594" descr="nucor_peer_processed.png"/>
+          <p:cNvPr id="618" name="Picture 617" descr="volkswagen_financial_services_ag_peer_processed.png"/>
+          <p:cNvPicPr>
+            <a:picLocks noChangeAspect="1"/>
+          </p:cNvPicPr>
+          <p:nvPr/>
+        </p:nvPicPr>
+        <p:blipFill>
+          <a:blip r:embed="rId11"/>
+          <a:stretch>
+            <a:fillRect/>
+          </a:stretch>
+        </p:blipFill>
+        <p:spPr>
+          <a:xfrm>
+            <a:off x="10018792" y="5617908"/>
+            <a:ext cx="174850" cy="174850"/>
+          </a:xfrm>
+          <a:prstGeom prst="rect">
+            <a:avLst/>
+          </a:prstGeom>
+        </p:spPr>
+      </p:pic>
+      <p:pic>
+        <p:nvPicPr>
+          <p:cNvPr id="619" name="Picture 618" descr="client_logo_processed.png"/>
+          <p:cNvPicPr>
+            <a:picLocks noChangeAspect="1"/>
+          </p:cNvPicPr>
+          <p:nvPr/>
+        </p:nvPicPr>
+        <p:blipFill>
+          <a:blip r:embed="rId7"/>
+          <a:stretch>
+            <a:fillRect/>
+          </a:stretch>
+        </p:blipFill>
+        <p:spPr>
+          <a:xfrm>
+            <a:off x="10198214" y="5617908"/>
+            <a:ext cx="335129" cy="174850"/>
+          </a:xfrm>
+          <a:prstGeom prst="rect">
+            <a:avLst/>
+          </a:prstGeom>
+        </p:spPr>
+      </p:pic>
+      <p:pic>
+        <p:nvPicPr>
+          <p:cNvPr id="620" name="Picture 619" descr="commerzbank_ag_peer_processed.png"/>
+          <p:cNvPicPr>
+            <a:picLocks noChangeAspect="1"/>
+          </p:cNvPicPr>
+          <p:nvPr/>
+        </p:nvPicPr>
+        <p:blipFill>
+          <a:blip r:embed="rId9"/>
+          <a:stretch>
+            <a:fillRect/>
+          </a:stretch>
+        </p:blipFill>
+        <p:spPr>
+          <a:xfrm>
+            <a:off x="11108797" y="5617908"/>
+            <a:ext cx="202049" cy="174850"/>
+          </a:xfrm>
+          <a:prstGeom prst="rect">
+            <a:avLst/>
+          </a:prstGeom>
+        </p:spPr>
+      </p:pic>
+      <p:pic>
+        <p:nvPicPr>
+          <p:cNvPr id="621" name="Picture 620" descr="deutsche_bank_ag_peer_processed.png"/>
           <p:cNvPicPr>
             <a:picLocks noChangeAspect="1"/>
           </p:cNvPicPr>
@@ -23446,8 +24070,8 @@
         </p:blipFill>
         <p:spPr>
           <a:xfrm>
-            <a:off x="10210768" y="3656530"/>
-            <a:ext cx="256455" cy="168474"/>
+            <a:off x="11315417" y="5617908"/>
+            <a:ext cx="170964" cy="174850"/>
           </a:xfrm>
           <a:prstGeom prst="rect">
             <a:avLst/>
@@ -23456,7 +24080,7 @@
       </p:pic>
       <p:pic>
         <p:nvPicPr>
-          <p:cNvPr id="596" name="Picture 595" descr="sidenor_peer_processed.png"/>
+          <p:cNvPr id="622" name="Picture 621" descr="volkswagen_financial_services_ag_peer_processed.png"/>
           <p:cNvPicPr>
             <a:picLocks noChangeAspect="1"/>
           </p:cNvPicPr>
@@ -23470,8 +24094,8 @@
         </p:blipFill>
         <p:spPr>
           <a:xfrm>
-            <a:off x="10471794" y="3656530"/>
-            <a:ext cx="168474" cy="168474"/>
+            <a:off x="8972361" y="6025720"/>
+            <a:ext cx="174850" cy="174850"/>
           </a:xfrm>
           <a:prstGeom prst="rect">
             <a:avLst/>
@@ -23480,7 +24104,31 @@
       </p:pic>
       <p:pic>
         <p:nvPicPr>
-          <p:cNvPr id="597" name="Picture 596" descr="megasa_peer_processed.png"/>
+          <p:cNvPr id="623" name="Picture 622" descr="bayerische_landesbank_peer_processed.png"/>
+          <p:cNvPicPr>
+            <a:picLocks noChangeAspect="1"/>
+          </p:cNvPicPr>
+          <p:nvPr/>
+        </p:nvPicPr>
+        <p:blipFill>
+          <a:blip r:embed="rId8"/>
+          <a:stretch>
+            <a:fillRect/>
+          </a:stretch>
+        </p:blipFill>
+        <p:spPr>
+          <a:xfrm>
+            <a:off x="9722666" y="6025720"/>
+            <a:ext cx="190188" cy="174850"/>
+          </a:xfrm>
+          <a:prstGeom prst="rect">
+            <a:avLst/>
+          </a:prstGeom>
+        </p:spPr>
+      </p:pic>
+      <p:pic>
+        <p:nvPicPr>
+          <p:cNvPr id="624" name="Picture 623" descr="commerzbank_ag_peer_processed.png"/>
           <p:cNvPicPr>
             <a:picLocks noChangeAspect="1"/>
           </p:cNvPicPr>
@@ -23494,8 +24142,8 @@
         </p:blipFill>
         <p:spPr>
           <a:xfrm>
-            <a:off x="8976455" y="4047909"/>
-            <a:ext cx="166662" cy="168474"/>
+            <a:off x="9917425" y="6025720"/>
+            <a:ext cx="202049" cy="174850"/>
           </a:xfrm>
           <a:prstGeom prst="rect">
             <a:avLst/>
@@ -23504,7 +24152,31 @@
       </p:pic>
       <p:pic>
         <p:nvPicPr>
-          <p:cNvPr id="598" name="Picture 597" descr="client_logo_processed.png"/>
+          <p:cNvPr id="625" name="Picture 624" descr="deutsche_bank_ag_peer_processed.png"/>
+          <p:cNvPicPr>
+            <a:picLocks noChangeAspect="1"/>
+          </p:cNvPicPr>
+          <p:nvPr/>
+        </p:nvPicPr>
+        <p:blipFill>
+          <a:blip r:embed="rId10"/>
+          <a:stretch>
+            <a:fillRect/>
+          </a:stretch>
+        </p:blipFill>
+        <p:spPr>
+          <a:xfrm>
+            <a:off x="10124045" y="6025720"/>
+            <a:ext cx="170964" cy="174850"/>
+          </a:xfrm>
+          <a:prstGeom prst="rect">
+            <a:avLst/>
+          </a:prstGeom>
+        </p:spPr>
+      </p:pic>
+      <p:pic>
+        <p:nvPicPr>
+          <p:cNvPr id="626" name="Picture 625" descr="client_logo_processed.png"/>
           <p:cNvPicPr>
             <a:picLocks noChangeAspect="1"/>
           </p:cNvPicPr>
@@ -23518,680 +24190,8 @@
         </p:blipFill>
         <p:spPr>
           <a:xfrm>
-            <a:off x="9717107" y="4047909"/>
-            <a:ext cx="156987" cy="168474"/>
-          </a:xfrm>
-          <a:prstGeom prst="rect">
-            <a:avLst/>
-          </a:prstGeom>
-        </p:spPr>
-      </p:pic>
-      <p:pic>
-        <p:nvPicPr>
-          <p:cNvPr id="599" name="Picture 598" descr="arcelormittal_peer_processed.png"/>
-          <p:cNvPicPr>
-            <a:picLocks noChangeAspect="1"/>
-          </p:cNvPicPr>
-          <p:nvPr/>
-        </p:nvPicPr>
-        <p:blipFill>
-          <a:blip r:embed="rId8"/>
-          <a:stretch>
-            <a:fillRect/>
-          </a:stretch>
-        </p:blipFill>
-        <p:spPr>
-          <a:xfrm>
-            <a:off x="9878666" y="4047909"/>
-            <a:ext cx="327530" cy="168474"/>
-          </a:xfrm>
-          <a:prstGeom prst="rect">
-            <a:avLst/>
-          </a:prstGeom>
-        </p:spPr>
-      </p:pic>
-      <p:pic>
-        <p:nvPicPr>
-          <p:cNvPr id="600" name="Picture 599" descr="nucor_peer_processed.png"/>
-          <p:cNvPicPr>
-            <a:picLocks noChangeAspect="1"/>
-          </p:cNvPicPr>
-          <p:nvPr/>
-        </p:nvPicPr>
-        <p:blipFill>
-          <a:blip r:embed="rId10"/>
-          <a:stretch>
-            <a:fillRect/>
-          </a:stretch>
-        </p:blipFill>
-        <p:spPr>
-          <a:xfrm>
-            <a:off x="10210768" y="4047909"/>
-            <a:ext cx="256455" cy="168474"/>
-          </a:xfrm>
-          <a:prstGeom prst="rect">
-            <a:avLst/>
-          </a:prstGeom>
-        </p:spPr>
-      </p:pic>
-      <p:pic>
-        <p:nvPicPr>
-          <p:cNvPr id="601" name="Picture 600" descr="sidenor_peer_processed.png"/>
-          <p:cNvPicPr>
-            <a:picLocks noChangeAspect="1"/>
-          </p:cNvPicPr>
-          <p:nvPr/>
-        </p:nvPicPr>
-        <p:blipFill>
-          <a:blip r:embed="rId11"/>
-          <a:stretch>
-            <a:fillRect/>
-          </a:stretch>
-        </p:blipFill>
-        <p:spPr>
-          <a:xfrm>
-            <a:off x="10471794" y="4047909"/>
-            <a:ext cx="168474" cy="168474"/>
-          </a:xfrm>
-          <a:prstGeom prst="rect">
-            <a:avLst/>
-          </a:prstGeom>
-        </p:spPr>
-      </p:pic>
-      <p:pic>
-        <p:nvPicPr>
-          <p:cNvPr id="602" name="Picture 601" descr="megasa_peer_processed.png"/>
-          <p:cNvPicPr>
-            <a:picLocks noChangeAspect="1"/>
-          </p:cNvPicPr>
-          <p:nvPr/>
-        </p:nvPicPr>
-        <p:blipFill>
-          <a:blip r:embed="rId9"/>
-          <a:stretch>
-            <a:fillRect/>
-          </a:stretch>
-        </p:blipFill>
-        <p:spPr>
-          <a:xfrm>
-            <a:off x="8889932" y="4441130"/>
-            <a:ext cx="166662" cy="168474"/>
-          </a:xfrm>
-          <a:prstGeom prst="rect">
-            <a:avLst/>
-          </a:prstGeom>
-        </p:spPr>
-      </p:pic>
-      <p:pic>
-        <p:nvPicPr>
-          <p:cNvPr id="603" name="Picture 602" descr="sidenor_peer_processed.png"/>
-          <p:cNvPicPr>
-            <a:picLocks noChangeAspect="1"/>
-          </p:cNvPicPr>
-          <p:nvPr/>
-        </p:nvPicPr>
-        <p:blipFill>
-          <a:blip r:embed="rId11"/>
-          <a:stretch>
-            <a:fillRect/>
-          </a:stretch>
-        </p:blipFill>
-        <p:spPr>
-          <a:xfrm>
-            <a:off x="9061166" y="4441130"/>
-            <a:ext cx="168474" cy="168474"/>
-          </a:xfrm>
-          <a:prstGeom prst="rect">
-            <a:avLst/>
-          </a:prstGeom>
-        </p:spPr>
-      </p:pic>
-      <p:pic>
-        <p:nvPicPr>
-          <p:cNvPr id="604" name="Picture 603" descr="client_logo_processed.png"/>
-          <p:cNvPicPr>
-            <a:picLocks noChangeAspect="1"/>
-          </p:cNvPicPr>
-          <p:nvPr/>
-        </p:nvPicPr>
-        <p:blipFill>
-          <a:blip r:embed="rId7"/>
-          <a:stretch>
-            <a:fillRect/>
-          </a:stretch>
-        </p:blipFill>
-        <p:spPr>
-          <a:xfrm>
-            <a:off x="9803630" y="4441130"/>
-            <a:ext cx="156987" cy="168474"/>
-          </a:xfrm>
-          <a:prstGeom prst="rect">
-            <a:avLst/>
-          </a:prstGeom>
-        </p:spPr>
-      </p:pic>
-      <p:pic>
-        <p:nvPicPr>
-          <p:cNvPr id="605" name="Picture 604" descr="arcelormittal_peer_processed.png"/>
-          <p:cNvPicPr>
-            <a:picLocks noChangeAspect="1"/>
-          </p:cNvPicPr>
-          <p:nvPr/>
-        </p:nvPicPr>
-        <p:blipFill>
-          <a:blip r:embed="rId8"/>
-          <a:stretch>
-            <a:fillRect/>
-          </a:stretch>
-        </p:blipFill>
-        <p:spPr>
-          <a:xfrm>
-            <a:off x="9965189" y="4441130"/>
-            <a:ext cx="327530" cy="168474"/>
-          </a:xfrm>
-          <a:prstGeom prst="rect">
-            <a:avLst/>
-          </a:prstGeom>
-        </p:spPr>
-      </p:pic>
-      <p:pic>
-        <p:nvPicPr>
-          <p:cNvPr id="606" name="Picture 605" descr="nucor_peer_processed.png"/>
-          <p:cNvPicPr>
-            <a:picLocks noChangeAspect="1"/>
-          </p:cNvPicPr>
-          <p:nvPr/>
-        </p:nvPicPr>
-        <p:blipFill>
-          <a:blip r:embed="rId10"/>
-          <a:stretch>
-            <a:fillRect/>
-          </a:stretch>
-        </p:blipFill>
-        <p:spPr>
-          <a:xfrm>
-            <a:off x="10297291" y="4441130"/>
-            <a:ext cx="256455" cy="168474"/>
-          </a:xfrm>
-          <a:prstGeom prst="rect">
-            <a:avLst/>
-          </a:prstGeom>
-        </p:spPr>
-      </p:pic>
-      <p:pic>
-        <p:nvPicPr>
-          <p:cNvPr id="607" name="Picture 606" descr="client_logo_processed.png"/>
-          <p:cNvPicPr>
-            <a:picLocks noChangeAspect="1"/>
-          </p:cNvPicPr>
-          <p:nvPr/>
-        </p:nvPicPr>
-        <p:blipFill>
-          <a:blip r:embed="rId7"/>
-          <a:stretch>
-            <a:fillRect/>
-          </a:stretch>
-        </p:blipFill>
-        <p:spPr>
-          <a:xfrm>
-            <a:off x="9797541" y="4835680"/>
-            <a:ext cx="156987" cy="168474"/>
-          </a:xfrm>
-          <a:prstGeom prst="rect">
-            <a:avLst/>
-          </a:prstGeom>
-        </p:spPr>
-      </p:pic>
-      <p:pic>
-        <p:nvPicPr>
-          <p:cNvPr id="608" name="Picture 607" descr="megasa_peer_processed.png"/>
-          <p:cNvPicPr>
-            <a:picLocks noChangeAspect="1"/>
-          </p:cNvPicPr>
-          <p:nvPr/>
-        </p:nvPicPr>
-        <p:blipFill>
-          <a:blip r:embed="rId9"/>
-          <a:stretch>
-            <a:fillRect/>
-          </a:stretch>
-        </p:blipFill>
-        <p:spPr>
-          <a:xfrm>
-            <a:off x="9959100" y="4835680"/>
-            <a:ext cx="166662" cy="168474"/>
-          </a:xfrm>
-          <a:prstGeom prst="rect">
-            <a:avLst/>
-          </a:prstGeom>
-        </p:spPr>
-      </p:pic>
-      <p:pic>
-        <p:nvPicPr>
-          <p:cNvPr id="609" name="Picture 608" descr="nucor_peer_processed.png"/>
-          <p:cNvPicPr>
-            <a:picLocks noChangeAspect="1"/>
-          </p:cNvPicPr>
-          <p:nvPr/>
-        </p:nvPicPr>
-        <p:blipFill>
-          <a:blip r:embed="rId10"/>
-          <a:stretch>
-            <a:fillRect/>
-          </a:stretch>
-        </p:blipFill>
-        <p:spPr>
-          <a:xfrm>
-            <a:off x="10130334" y="4835680"/>
-            <a:ext cx="256455" cy="168474"/>
-          </a:xfrm>
-          <a:prstGeom prst="rect">
-            <a:avLst/>
-          </a:prstGeom>
-        </p:spPr>
-      </p:pic>
-      <p:pic>
-        <p:nvPicPr>
-          <p:cNvPr id="610" name="Picture 609" descr="sidenor_peer_processed.png"/>
-          <p:cNvPicPr>
-            <a:picLocks noChangeAspect="1"/>
-          </p:cNvPicPr>
-          <p:nvPr/>
-        </p:nvPicPr>
-        <p:blipFill>
-          <a:blip r:embed="rId11"/>
-          <a:stretch>
-            <a:fillRect/>
-          </a:stretch>
-        </p:blipFill>
-        <p:spPr>
-          <a:xfrm>
-            <a:off x="10391360" y="4835680"/>
-            <a:ext cx="168474" cy="168474"/>
-          </a:xfrm>
-          <a:prstGeom prst="rect">
-            <a:avLst/>
-          </a:prstGeom>
-        </p:spPr>
-      </p:pic>
-      <p:pic>
-        <p:nvPicPr>
-          <p:cNvPr id="611" name="Picture 610" descr="arcelormittal_peer_processed.png"/>
-          <p:cNvPicPr>
-            <a:picLocks noChangeAspect="1"/>
-          </p:cNvPicPr>
-          <p:nvPr/>
-        </p:nvPicPr>
-        <p:blipFill>
-          <a:blip r:embed="rId8"/>
-          <a:stretch>
-            <a:fillRect/>
-          </a:stretch>
-        </p:blipFill>
-        <p:spPr>
-          <a:xfrm>
-            <a:off x="11133824" y="4835680"/>
-            <a:ext cx="327530" cy="168474"/>
-          </a:xfrm>
-          <a:prstGeom prst="rect">
-            <a:avLst/>
-          </a:prstGeom>
-        </p:spPr>
-      </p:pic>
-      <p:pic>
-        <p:nvPicPr>
-          <p:cNvPr id="612" name="Picture 611" descr="megasa_peer_processed.png"/>
-          <p:cNvPicPr>
-            <a:picLocks noChangeAspect="1"/>
-          </p:cNvPicPr>
-          <p:nvPr/>
-        </p:nvPicPr>
-        <p:blipFill>
-          <a:blip r:embed="rId9"/>
-          <a:stretch>
-            <a:fillRect/>
-          </a:stretch>
-        </p:blipFill>
-        <p:spPr>
-          <a:xfrm>
-            <a:off x="8976455" y="5228388"/>
-            <a:ext cx="166662" cy="168474"/>
-          </a:xfrm>
-          <a:prstGeom prst="rect">
-            <a:avLst/>
-          </a:prstGeom>
-        </p:spPr>
-      </p:pic>
-      <p:pic>
-        <p:nvPicPr>
-          <p:cNvPr id="613" name="Picture 612" descr="client_logo_processed.png"/>
-          <p:cNvPicPr>
-            <a:picLocks noChangeAspect="1"/>
-          </p:cNvPicPr>
-          <p:nvPr/>
-        </p:nvPicPr>
-        <p:blipFill>
-          <a:blip r:embed="rId7"/>
-          <a:stretch>
-            <a:fillRect/>
-          </a:stretch>
-        </p:blipFill>
-        <p:spPr>
-          <a:xfrm>
-            <a:off x="9717107" y="5228388"/>
-            <a:ext cx="156987" cy="168474"/>
-          </a:xfrm>
-          <a:prstGeom prst="rect">
-            <a:avLst/>
-          </a:prstGeom>
-        </p:spPr>
-      </p:pic>
-      <p:pic>
-        <p:nvPicPr>
-          <p:cNvPr id="614" name="Picture 613" descr="arcelormittal_peer_processed.png"/>
-          <p:cNvPicPr>
-            <a:picLocks noChangeAspect="1"/>
-          </p:cNvPicPr>
-          <p:nvPr/>
-        </p:nvPicPr>
-        <p:blipFill>
-          <a:blip r:embed="rId8"/>
-          <a:stretch>
-            <a:fillRect/>
-          </a:stretch>
-        </p:blipFill>
-        <p:spPr>
-          <a:xfrm>
-            <a:off x="9878666" y="5228388"/>
-            <a:ext cx="327530" cy="168474"/>
-          </a:xfrm>
-          <a:prstGeom prst="rect">
-            <a:avLst/>
-          </a:prstGeom>
-        </p:spPr>
-      </p:pic>
-      <p:pic>
-        <p:nvPicPr>
-          <p:cNvPr id="615" name="Picture 614" descr="nucor_peer_processed.png"/>
-          <p:cNvPicPr>
-            <a:picLocks noChangeAspect="1"/>
-          </p:cNvPicPr>
-          <p:nvPr/>
-        </p:nvPicPr>
-        <p:blipFill>
-          <a:blip r:embed="rId10"/>
-          <a:stretch>
-            <a:fillRect/>
-          </a:stretch>
-        </p:blipFill>
-        <p:spPr>
-          <a:xfrm>
-            <a:off x="10210768" y="5228388"/>
-            <a:ext cx="256455" cy="168474"/>
-          </a:xfrm>
-          <a:prstGeom prst="rect">
-            <a:avLst/>
-          </a:prstGeom>
-        </p:spPr>
-      </p:pic>
-      <p:pic>
-        <p:nvPicPr>
-          <p:cNvPr id="616" name="Picture 615" descr="sidenor_peer_processed.png"/>
-          <p:cNvPicPr>
-            <a:picLocks noChangeAspect="1"/>
-          </p:cNvPicPr>
-          <p:nvPr/>
-        </p:nvPicPr>
-        <p:blipFill>
-          <a:blip r:embed="rId11"/>
-          <a:stretch>
-            <a:fillRect/>
-          </a:stretch>
-        </p:blipFill>
-        <p:spPr>
-          <a:xfrm>
-            <a:off x="10471794" y="5228388"/>
-            <a:ext cx="168474" cy="168474"/>
-          </a:xfrm>
-          <a:prstGeom prst="rect">
-            <a:avLst/>
-          </a:prstGeom>
-        </p:spPr>
-      </p:pic>
-      <p:pic>
-        <p:nvPicPr>
-          <p:cNvPr id="617" name="Picture 616" descr="megasa_peer_processed.png"/>
-          <p:cNvPicPr>
-            <a:picLocks noChangeAspect="1"/>
-          </p:cNvPicPr>
-          <p:nvPr/>
-        </p:nvPicPr>
-        <p:blipFill>
-          <a:blip r:embed="rId9"/>
-          <a:stretch>
-            <a:fillRect/>
-          </a:stretch>
-        </p:blipFill>
-        <p:spPr>
-          <a:xfrm>
-            <a:off x="8976455" y="5621096"/>
-            <a:ext cx="166662" cy="168474"/>
-          </a:xfrm>
-          <a:prstGeom prst="rect">
-            <a:avLst/>
-          </a:prstGeom>
-        </p:spPr>
-      </p:pic>
-      <p:pic>
-        <p:nvPicPr>
-          <p:cNvPr id="618" name="Picture 617" descr="client_logo_processed.png"/>
-          <p:cNvPicPr>
-            <a:picLocks noChangeAspect="1"/>
-          </p:cNvPicPr>
-          <p:nvPr/>
-        </p:nvPicPr>
-        <p:blipFill>
-          <a:blip r:embed="rId7"/>
-          <a:stretch>
-            <a:fillRect/>
-          </a:stretch>
-        </p:blipFill>
-        <p:spPr>
-          <a:xfrm>
-            <a:off x="9717107" y="5621096"/>
-            <a:ext cx="156987" cy="168474"/>
-          </a:xfrm>
-          <a:prstGeom prst="rect">
-            <a:avLst/>
-          </a:prstGeom>
-        </p:spPr>
-      </p:pic>
-      <p:pic>
-        <p:nvPicPr>
-          <p:cNvPr id="619" name="Picture 618" descr="arcelormittal_peer_processed.png"/>
-          <p:cNvPicPr>
-            <a:picLocks noChangeAspect="1"/>
-          </p:cNvPicPr>
-          <p:nvPr/>
-        </p:nvPicPr>
-        <p:blipFill>
-          <a:blip r:embed="rId8"/>
-          <a:stretch>
-            <a:fillRect/>
-          </a:stretch>
-        </p:blipFill>
-        <p:spPr>
-          <a:xfrm>
-            <a:off x="9878666" y="5621096"/>
-            <a:ext cx="327530" cy="168474"/>
-          </a:xfrm>
-          <a:prstGeom prst="rect">
-            <a:avLst/>
-          </a:prstGeom>
-        </p:spPr>
-      </p:pic>
-      <p:pic>
-        <p:nvPicPr>
-          <p:cNvPr id="620" name="Picture 619" descr="nucor_peer_processed.png"/>
-          <p:cNvPicPr>
-            <a:picLocks noChangeAspect="1"/>
-          </p:cNvPicPr>
-          <p:nvPr/>
-        </p:nvPicPr>
-        <p:blipFill>
-          <a:blip r:embed="rId10"/>
-          <a:stretch>
-            <a:fillRect/>
-          </a:stretch>
-        </p:blipFill>
-        <p:spPr>
-          <a:xfrm>
-            <a:off x="10210768" y="5621096"/>
-            <a:ext cx="256455" cy="168474"/>
-          </a:xfrm>
-          <a:prstGeom prst="rect">
-            <a:avLst/>
-          </a:prstGeom>
-        </p:spPr>
-      </p:pic>
-      <p:pic>
-        <p:nvPicPr>
-          <p:cNvPr id="621" name="Picture 620" descr="sidenor_peer_processed.png"/>
-          <p:cNvPicPr>
-            <a:picLocks noChangeAspect="1"/>
-          </p:cNvPicPr>
-          <p:nvPr/>
-        </p:nvPicPr>
-        <p:blipFill>
-          <a:blip r:embed="rId11"/>
-          <a:stretch>
-            <a:fillRect/>
-          </a:stretch>
-        </p:blipFill>
-        <p:spPr>
-          <a:xfrm>
-            <a:off x="10471794" y="5621096"/>
-            <a:ext cx="168474" cy="168474"/>
-          </a:xfrm>
-          <a:prstGeom prst="rect">
-            <a:avLst/>
-          </a:prstGeom>
-        </p:spPr>
-      </p:pic>
-      <p:pic>
-        <p:nvPicPr>
-          <p:cNvPr id="622" name="Picture 621" descr="client_logo_processed.png"/>
-          <p:cNvPicPr>
-            <a:picLocks noChangeAspect="1"/>
-          </p:cNvPicPr>
-          <p:nvPr/>
-        </p:nvPicPr>
-        <p:blipFill>
-          <a:blip r:embed="rId7"/>
-          <a:stretch>
-            <a:fillRect/>
-          </a:stretch>
-        </p:blipFill>
-        <p:spPr>
-          <a:xfrm>
-            <a:off x="8684729" y="6028908"/>
-            <a:ext cx="156987" cy="168474"/>
-          </a:xfrm>
-          <a:prstGeom prst="rect">
-            <a:avLst/>
-          </a:prstGeom>
-        </p:spPr>
-      </p:pic>
-      <p:pic>
-        <p:nvPicPr>
-          <p:cNvPr id="623" name="Picture 622" descr="arcelormittal_peer_processed.png"/>
-          <p:cNvPicPr>
-            <a:picLocks noChangeAspect="1"/>
-          </p:cNvPicPr>
-          <p:nvPr/>
-        </p:nvPicPr>
-        <p:blipFill>
-          <a:blip r:embed="rId8"/>
-          <a:stretch>
-            <a:fillRect/>
-          </a:stretch>
-        </p:blipFill>
-        <p:spPr>
-          <a:xfrm>
-            <a:off x="8846288" y="6028908"/>
-            <a:ext cx="327530" cy="168474"/>
-          </a:xfrm>
-          <a:prstGeom prst="rect">
-            <a:avLst/>
-          </a:prstGeom>
-        </p:spPr>
-      </p:pic>
-      <p:pic>
-        <p:nvPicPr>
-          <p:cNvPr id="624" name="Picture 623" descr="nucor_peer_processed.png"/>
-          <p:cNvPicPr>
-            <a:picLocks noChangeAspect="1"/>
-          </p:cNvPicPr>
-          <p:nvPr/>
-        </p:nvPicPr>
-        <p:blipFill>
-          <a:blip r:embed="rId10"/>
-          <a:stretch>
-            <a:fillRect/>
-          </a:stretch>
-        </p:blipFill>
-        <p:spPr>
-          <a:xfrm>
-            <a:off x="9178390" y="6028908"/>
-            <a:ext cx="256455" cy="168474"/>
-          </a:xfrm>
-          <a:prstGeom prst="rect">
-            <a:avLst/>
-          </a:prstGeom>
-        </p:spPr>
-      </p:pic>
-      <p:pic>
-        <p:nvPicPr>
-          <p:cNvPr id="625" name="Picture 624" descr="megasa_peer_processed.png"/>
-          <p:cNvPicPr>
-            <a:picLocks noChangeAspect="1"/>
-          </p:cNvPicPr>
-          <p:nvPr/>
-        </p:nvPicPr>
-        <p:blipFill>
-          <a:blip r:embed="rId9"/>
-          <a:stretch>
-            <a:fillRect/>
-          </a:stretch>
-        </p:blipFill>
-        <p:spPr>
-          <a:xfrm>
-            <a:off x="10008834" y="6028908"/>
-            <a:ext cx="166662" cy="168474"/>
-          </a:xfrm>
-          <a:prstGeom prst="rect">
-            <a:avLst/>
-          </a:prstGeom>
-        </p:spPr>
-      </p:pic>
-      <p:pic>
-        <p:nvPicPr>
-          <p:cNvPr id="626" name="Picture 625" descr="sidenor_peer_processed.png"/>
-          <p:cNvPicPr>
-            <a:picLocks noChangeAspect="1"/>
-          </p:cNvPicPr>
-          <p:nvPr/>
-        </p:nvPicPr>
-        <p:blipFill>
-          <a:blip r:embed="rId11"/>
-          <a:stretch>
-            <a:fillRect/>
-          </a:stretch>
-        </p:blipFill>
-        <p:spPr>
-          <a:xfrm>
-            <a:off x="10180068" y="6028908"/>
-            <a:ext cx="168474" cy="168474"/>
+            <a:off x="10299581" y="6025720"/>
+            <a:ext cx="335129" cy="174850"/>
           </a:xfrm>
           <a:prstGeom prst="rect">
             <a:avLst/>

</xml_diff>